<commit_message>
docs: add agent factory architecture to deck
</commit_message>
<xml_diff>
--- a/Claude_Harness_Engine_Design.pptx
+++ b/Claude_Harness_Engine_Design.pptx
@@ -35,6 +35,10 @@
     <p:sldId id="283" r:id="rId34"/>
     <p:sldId id="284" r:id="rId35"/>
     <p:sldId id="285" r:id="rId36"/>
+    <p:sldId id="286" r:id="rId37"/>
+    <p:sldId id="287" r:id="rId38"/>
+    <p:sldId id="288" r:id="rId39"/>
+    <p:sldId id="289" r:id="rId40"/>
   </p:sldIdLst>
   <p:sldSz cx="9144000" cy="5143500" type="screen4x3"/>
   <p:notesSz cx="6858000" cy="9144000"/>
@@ -3277,7 +3281,7 @@
                 </a:solidFill>
                 <a:latin typeface="Calibri"/>
               </a:rPr>
-              <a:t>Claude Harness Engine v1.1.1</a:t>
+              <a:t>Claude Harness Engine v1.1.4</a:t>
             </a:r>
           </a:p>
         </p:txBody>
@@ -3402,7 +3406,7 @@
                 </a:solidFill>
                 <a:latin typeface="Calibri"/>
               </a:rPr>
-              <a:t>21 SKILLS</a:t>
+              <a:t>23 SKILLS</a:t>
             </a:r>
           </a:p>
         </p:txBody>
@@ -3512,7 +3516,7 @@
                 </a:solidFill>
                 <a:latin typeface="Calibri"/>
               </a:rPr>
-              <a:t>14 HOOKS</a:t>
+              <a:t>15 HOOKS</a:t>
             </a:r>
           </a:p>
         </p:txBody>
@@ -4945,7 +4949,7 @@
                 </a:solidFill>
                 <a:latin typeface="Calibri"/>
               </a:rPr>
-              <a:t>Claude Harness Engine v1.1.1   ·   Autonomous SDLC for Agentic Software</a:t>
+              <a:t>Claude Harness Engine v1.1.4   ·   Autonomous SDLC for Agentic Software</a:t>
             </a:r>
           </a:p>
         </p:txBody>
@@ -4980,7 +4984,7 @@
                 </a:solidFill>
                 <a:latin typeface="Calibri"/>
               </a:rPr>
-              <a:t>10 / 30</a:t>
+              <a:t>10 / 34</a:t>
             </a:r>
           </a:p>
         </p:txBody>
@@ -6632,7 +6636,7 @@
                 </a:solidFill>
                 <a:latin typeface="Calibri"/>
               </a:rPr>
-              <a:t>Claude Harness Engine v1.1.1   ·   Autonomous SDLC for Agentic Software</a:t>
+              <a:t>Claude Harness Engine v1.1.4   ·   Autonomous SDLC for Agentic Software</a:t>
             </a:r>
           </a:p>
         </p:txBody>
@@ -6667,7 +6671,7 @@
                 </a:solidFill>
                 <a:latin typeface="Calibri"/>
               </a:rPr>
-              <a:t>11 / 30</a:t>
+              <a:t>11 / 34</a:t>
             </a:r>
           </a:p>
         </p:txBody>
@@ -6807,7 +6811,7 @@
                 </a:solidFill>
                 <a:latin typeface="Calibri"/>
               </a:rPr>
-              <a:t>Hooks — 14 Enforcement Layers Wired in `settings.json`</a:t>
+              <a:t>Hooks — 15 Enforcement Layers Wired in `settings.json`</a:t>
             </a:r>
           </a:p>
         </p:txBody>
@@ -8774,7 +8778,7 @@
                 </a:solidFill>
                 <a:latin typeface="Calibri"/>
               </a:rPr>
-              <a:t>Claude Harness Engine v1.1.1   ·   Autonomous SDLC for Agentic Software</a:t>
+              <a:t>Claude Harness Engine v1.1.4   ·   Autonomous SDLC for Agentic Software</a:t>
             </a:r>
           </a:p>
         </p:txBody>
@@ -8809,7 +8813,7 @@
                 </a:solidFill>
                 <a:latin typeface="Calibri"/>
               </a:rPr>
-              <a:t>12 / 30</a:t>
+              <a:t>12 / 34</a:t>
             </a:r>
           </a:p>
         </p:txBody>
@@ -9840,7 +9844,7 @@
                 </a:solidFill>
                 <a:latin typeface="Calibri"/>
               </a:rPr>
-              <a:t>Claude Harness Engine v1.1.1   ·   Autonomous SDLC for Agentic Software</a:t>
+              <a:t>Claude Harness Engine v1.1.4   ·   Autonomous SDLC for Agentic Software</a:t>
             </a:r>
           </a:p>
         </p:txBody>
@@ -9875,7 +9879,7 @@
                 </a:solidFill>
                 <a:latin typeface="Calibri"/>
               </a:rPr>
-              <a:t>13 / 30</a:t>
+              <a:t>13 / 34</a:t>
             </a:r>
           </a:p>
         </p:txBody>
@@ -12225,7 +12229,7 @@
                 </a:solidFill>
                 <a:latin typeface="Calibri"/>
               </a:rPr>
-              <a:t>Claude Harness Engine v1.1.1   ·   Autonomous SDLC for Agentic Software</a:t>
+              <a:t>Claude Harness Engine v1.1.4   ·   Autonomous SDLC for Agentic Software</a:t>
             </a:r>
           </a:p>
         </p:txBody>
@@ -12260,7 +12264,7 @@
                 </a:solidFill>
                 <a:latin typeface="Calibri"/>
               </a:rPr>
-              <a:t>14 / 30</a:t>
+              <a:t>14 / 34</a:t>
             </a:r>
           </a:p>
         </p:txBody>
@@ -12435,7 +12439,7 @@
                 </a:solidFill>
                 <a:latin typeface="Calibri"/>
               </a:rPr>
-              <a:t>Two new lanes added in v1.1.1 to handle reality: existing code and tiny low-risk edits</a:t>
+              <a:t>Two new lanes added in v1.1.4 to handle reality: existing code and tiny low-risk edits</a:t>
             </a:r>
           </a:p>
         </p:txBody>
@@ -13080,7 +13084,7 @@
                 </a:solidFill>
                 <a:latin typeface="Calibri"/>
               </a:rPr>
-              <a:t>Claude Harness Engine v1.1.1   ·   Autonomous SDLC for Agentic Software</a:t>
+              <a:t>Claude Harness Engine v1.1.4   ·   Autonomous SDLC for Agentic Software</a:t>
             </a:r>
           </a:p>
         </p:txBody>
@@ -13115,7 +13119,7 @@
                 </a:solidFill>
                 <a:latin typeface="Calibri"/>
               </a:rPr>
-              <a:t>15 / 30</a:t>
+              <a:t>15 / 34</a:t>
             </a:r>
           </a:p>
         </p:txBody>
@@ -14716,7 +14720,7 @@
                 </a:solidFill>
                 <a:latin typeface="Calibri"/>
               </a:rPr>
-              <a:t>Claude Harness Engine v1.1.1   ·   Autonomous SDLC for Agentic Software</a:t>
+              <a:t>Claude Harness Engine v1.1.4   ·   Autonomous SDLC for Agentic Software</a:t>
             </a:r>
           </a:p>
         </p:txBody>
@@ -14751,7 +14755,7 @@
                 </a:solidFill>
                 <a:latin typeface="Calibri"/>
               </a:rPr>
-              <a:t>16 / 30</a:t>
+              <a:t>16 / 34</a:t>
             </a:r>
           </a:p>
         </p:txBody>
@@ -16571,7 +16575,7 @@
                 </a:solidFill>
                 <a:latin typeface="Calibri"/>
               </a:rPr>
-              <a:t>Claude Harness Engine v1.1.1   ·   Autonomous SDLC for Agentic Software</a:t>
+              <a:t>Claude Harness Engine v1.1.4   ·   Autonomous SDLC for Agentic Software</a:t>
             </a:r>
           </a:p>
         </p:txBody>
@@ -16606,7 +16610,7 @@
                 </a:solidFill>
                 <a:latin typeface="Calibri"/>
               </a:rPr>
-              <a:t>17 / 30</a:t>
+              <a:t>17 / 34</a:t>
             </a:r>
           </a:p>
         </p:txBody>
@@ -17336,7 +17340,7 @@
                 </a:solidFill>
                 <a:latin typeface="Calibri"/>
               </a:rPr>
-              <a:t>Claude Harness Engine v1.1.1   ·   Autonomous SDLC for Agentic Software</a:t>
+              <a:t>Claude Harness Engine v1.1.4   ·   Autonomous SDLC for Agentic Software</a:t>
             </a:r>
           </a:p>
         </p:txBody>
@@ -17371,7 +17375,7 @@
                 </a:solidFill>
                 <a:latin typeface="Calibri"/>
               </a:rPr>
-              <a:t>18 / 30</a:t>
+              <a:t>18 / 34</a:t>
             </a:r>
           </a:p>
         </p:txBody>
@@ -18016,7 +18020,7 @@
                 </a:solidFill>
                 <a:latin typeface="Calibri"/>
               </a:rPr>
-              <a:t>Claude Harness Engine v1.1.1   ·   Autonomous SDLC for Agentic Software</a:t>
+              <a:t>Claude Harness Engine v1.1.4   ·   Autonomous SDLC for Agentic Software</a:t>
             </a:r>
           </a:p>
         </p:txBody>
@@ -18051,7 +18055,7 @@
                 </a:solidFill>
                 <a:latin typeface="Calibri"/>
               </a:rPr>
-              <a:t>19 / 30</a:t>
+              <a:t>19 / 34</a:t>
             </a:r>
           </a:p>
         </p:txBody>
@@ -18191,7 +18195,7 @@
                 </a:solidFill>
                 <a:latin typeface="Calibri"/>
               </a:rPr>
-              <a:t>What's New in v1.1.1</a:t>
+              <a:t>What's New in v1.1.4</a:t>
             </a:r>
           </a:p>
         </p:txBody>
@@ -18226,7 +18230,7 @@
                 </a:solidFill>
                 <a:latin typeface="Calibri"/>
               </a:rPr>
-              <a:t>Updates since the original deck — codebase has grown along five axes</a:t>
+              <a:t>Updates since the original deck — codebase now spans scaffold, lanes, plugins, hooks, and tracker orchestration</a:t>
             </a:r>
           </a:p>
         </p:txBody>
@@ -18826,7 +18830,7 @@
                 </a:solidFill>
                 <a:latin typeface="Calibri"/>
               </a:rPr>
-              <a:t>14 hooks (was 12): pre-tool length gate, track-writes ledger, require-review Stop hook, sprint-contract-gate on commits.</a:t>
+              <a:t>15 hooks: pre-tool length gate, tracker-safe env protection, track-writes ledger, require-review Stop hook, sprint-contract-gate on commits.</a:t>
             </a:r>
           </a:p>
         </p:txBody>
@@ -19016,7 +19020,7 @@
                 </a:solidFill>
                 <a:latin typeface="Calibri"/>
               </a:rPr>
-              <a:t>Claude Harness Engine v1.1.1   ·   Autonomous SDLC for Agentic Software</a:t>
+              <a:t>Claude Harness Engine v1.1.4   ·   Autonomous SDLC for Agentic Software</a:t>
             </a:r>
           </a:p>
         </p:txBody>
@@ -19051,7 +19055,7 @@
                 </a:solidFill>
                 <a:latin typeface="Calibri"/>
               </a:rPr>
-              <a:t>2 / 30</a:t>
+              <a:t>2 / 34</a:t>
             </a:r>
           </a:p>
         </p:txBody>
@@ -19824,7 +19828,7 @@
                 </a:solidFill>
                 <a:latin typeface="Calibri"/>
               </a:rPr>
-              <a:t>Claude Harness Engine v1.1.1   ·   Autonomous SDLC for Agentic Software</a:t>
+              <a:t>Claude Harness Engine v1.1.4   ·   Autonomous SDLC for Agentic Software</a:t>
             </a:r>
           </a:p>
         </p:txBody>
@@ -19859,7 +19863,7 @@
                 </a:solidFill>
                 <a:latin typeface="Calibri"/>
               </a:rPr>
-              <a:t>20 / 30</a:t>
+              <a:t>20 / 34</a:t>
             </a:r>
           </a:p>
         </p:txBody>
@@ -21219,7 +21223,7 @@
                 </a:solidFill>
                 <a:latin typeface="Calibri"/>
               </a:rPr>
-              <a:t>Claude Harness Engine v1.1.1   ·   Autonomous SDLC for Agentic Software</a:t>
+              <a:t>Claude Harness Engine v1.1.4   ·   Autonomous SDLC for Agentic Software</a:t>
             </a:r>
           </a:p>
         </p:txBody>
@@ -21254,7 +21258,7 @@
                 </a:solidFill>
                 <a:latin typeface="Calibri"/>
               </a:rPr>
-              <a:t>21 / 30</a:t>
+              <a:t>21 / 34</a:t>
             </a:r>
           </a:p>
         </p:txBody>
@@ -22663,7 +22667,7 @@
                 </a:solidFill>
                 <a:latin typeface="Calibri"/>
               </a:rPr>
-              <a:t>Claude Harness Engine v1.1.1   ·   Autonomous SDLC for Agentic Software</a:t>
+              <a:t>Claude Harness Engine v1.1.4   ·   Autonomous SDLC for Agentic Software</a:t>
             </a:r>
           </a:p>
         </p:txBody>
@@ -22698,7 +22702,7 @@
                 </a:solidFill>
                 <a:latin typeface="Calibri"/>
               </a:rPr>
-              <a:t>22 / 30</a:t>
+              <a:t>22 / 34</a:t>
             </a:r>
           </a:p>
         </p:txBody>
@@ -23776,7 +23780,7 @@
                 </a:solidFill>
                 <a:latin typeface="Calibri"/>
               </a:rPr>
-              <a:t>Claude Harness Engine v1.1.1   ·   Autonomous SDLC for Agentic Software</a:t>
+              <a:t>Claude Harness Engine v1.1.4   ·   Autonomous SDLC for Agentic Software</a:t>
             </a:r>
           </a:p>
         </p:txBody>
@@ -23811,7 +23815,7 @@
                 </a:solidFill>
                 <a:latin typeface="Calibri"/>
               </a:rPr>
-              <a:t>23 / 30</a:t>
+              <a:t>23 / 34</a:t>
             </a:r>
           </a:p>
         </p:txBody>
@@ -24881,7 +24885,7 @@
                 </a:solidFill>
                 <a:latin typeface="Calibri"/>
               </a:rPr>
-              <a:t>Claude Harness Engine v1.1.1   ·   Autonomous SDLC for Agentic Software</a:t>
+              <a:t>Claude Harness Engine v1.1.4   ·   Autonomous SDLC for Agentic Software</a:t>
             </a:r>
           </a:p>
         </p:txBody>
@@ -24916,7 +24920,7 @@
                 </a:solidFill>
                 <a:latin typeface="Calibri"/>
               </a:rPr>
-              <a:t>24 / 30</a:t>
+              <a:t>24 / 34</a:t>
             </a:r>
           </a:p>
         </p:txBody>
@@ -26089,7 +26093,7 @@
                 </a:solidFill>
                 <a:latin typeface="Calibri"/>
               </a:rPr>
-              <a:t>Claude Harness Engine v1.1.1   ·   Autonomous SDLC for Agentic Software</a:t>
+              <a:t>Claude Harness Engine v1.1.4   ·   Autonomous SDLC for Agentic Software</a:t>
             </a:r>
           </a:p>
         </p:txBody>
@@ -26124,7 +26128,7 @@
                 </a:solidFill>
                 <a:latin typeface="Calibri"/>
               </a:rPr>
-              <a:t>25 / 30</a:t>
+              <a:t>25 / 34</a:t>
             </a:r>
           </a:p>
         </p:txBody>
@@ -26896,7 +26900,7 @@
                 </a:solidFill>
                 <a:latin typeface="Calibri"/>
               </a:rPr>
-              <a:t>Claude Harness Engine v1.1.1   ·   Autonomous SDLC for Agentic Software</a:t>
+              <a:t>Claude Harness Engine v1.1.4   ·   Autonomous SDLC for Agentic Software</a:t>
             </a:r>
           </a:p>
         </p:txBody>
@@ -26931,7 +26935,7 @@
                 </a:solidFill>
                 <a:latin typeface="Calibri"/>
               </a:rPr>
-              <a:t>26 / 30</a:t>
+              <a:t>26 / 34</a:t>
             </a:r>
           </a:p>
         </p:txBody>
@@ -28268,7 +28272,7 @@
                 </a:solidFill>
                 <a:latin typeface="Calibri"/>
               </a:rPr>
-              <a:t>14 hooks + 6 ratchet gates on every edit</a:t>
+              <a:t>15 hooks + 6 ratchet gates on every edit</a:t>
             </a:r>
           </a:p>
         </p:txBody>
@@ -28303,7 +28307,7 @@
                 </a:solidFill>
                 <a:latin typeface="Calibri"/>
               </a:rPr>
-              <a:t>Claude Harness Engine v1.1.1   ·   Autonomous SDLC for Agentic Software</a:t>
+              <a:t>Claude Harness Engine v1.1.4   ·   Autonomous SDLC for Agentic Software</a:t>
             </a:r>
           </a:p>
         </p:txBody>
@@ -28338,7 +28342,7 @@
                 </a:solidFill>
                 <a:latin typeface="Calibri"/>
               </a:rPr>
-              <a:t>27 / 30</a:t>
+              <a:t>27 / 34</a:t>
             </a:r>
           </a:p>
         </p:txBody>
@@ -29241,7 +29245,7 @@
                 </a:solidFill>
                 <a:latin typeface="Calibri"/>
               </a:rPr>
-              <a:t>Claude Harness Engine v1.1.1   ·   Autonomous SDLC for Agentic Software</a:t>
+              <a:t>Claude Harness Engine v1.1.4   ·   Autonomous SDLC for Agentic Software</a:t>
             </a:r>
           </a:p>
         </p:txBody>
@@ -29276,7 +29280,7 @@
                 </a:solidFill>
                 <a:latin typeface="Calibri"/>
               </a:rPr>
-              <a:t>28 / 30</a:t>
+              <a:t>28 / 34</a:t>
             </a:r>
           </a:p>
         </p:txBody>
@@ -29935,7 +29939,7 @@
                 </a:solidFill>
                 <a:latin typeface="Calibri"/>
               </a:rPr>
-              <a:t>Claude Harness Engine v1.1.1   ·   Autonomous SDLC for Agentic Software</a:t>
+              <a:t>Claude Harness Engine v1.1.4   ·   Autonomous SDLC for Agentic Software</a:t>
             </a:r>
           </a:p>
         </p:txBody>
@@ -29970,7 +29974,7 @@
                 </a:solidFill>
                 <a:latin typeface="Calibri"/>
               </a:rPr>
-              <a:t>29 / 30</a:t>
+              <a:t>29 / 34</a:t>
             </a:r>
           </a:p>
         </p:txBody>
@@ -30695,7 +30699,7 @@
                 </a:solidFill>
                 <a:latin typeface="Calibri"/>
               </a:rPr>
-              <a:t>Claude Harness Engine v1.1.1   ·   Autonomous SDLC for Agentic Software</a:t>
+              <a:t>Claude Harness Engine v1.1.4   ·   Autonomous SDLC for Agentic Software</a:t>
             </a:r>
           </a:p>
         </p:txBody>
@@ -30730,7 +30734,7 @@
                 </a:solidFill>
                 <a:latin typeface="Calibri"/>
               </a:rPr>
-              <a:t>3 / 30</a:t>
+              <a:t>3 / 34</a:t>
             </a:r>
           </a:p>
         </p:txBody>
@@ -31452,7 +31456,7 @@
                 </a:solidFill>
                 <a:latin typeface="Calibri"/>
               </a:rPr>
-              <a:t>One real `/scaffold` command bootstraps a runtime where 21 skills act as virtual commands. Keeps context cheap and discovery progressive.</a:t>
+              <a:t>One real `/scaffold` command bootstraps a runtime where 23 skills act as virtual commands. Keeps context cheap and discovery progressive.</a:t>
             </a:r>
           </a:p>
         </p:txBody>
@@ -31646,7 +31650,7 @@
                 </a:solidFill>
                 <a:latin typeface="Calibri"/>
               </a:rPr>
-              <a:t>Two new lanes in v1.1.1 make the harness adaptable to real codebases and tiny safe edits, without bypassing the ratchet.</a:t>
+              <a:t>Two new lanes in v1.1.4 make the harness adaptable to real codebases and tiny safe edits, without bypassing the ratchet.</a:t>
             </a:r>
           </a:p>
         </p:txBody>
@@ -31875,7 +31879,7 @@
                 </a:solidFill>
                 <a:latin typeface="Calibri"/>
               </a:rPr>
-              <a:t>Claude Harness Engine v1.1.1  —  Autonomous SDLC for the Age of Agents</a:t>
+              <a:t>Claude Harness Engine v1.1.4  —  Autonomous SDLC for the Age of Agents</a:t>
             </a:r>
           </a:p>
         </p:txBody>
@@ -31910,7 +31914,7 @@
                 </a:solidFill>
                 <a:latin typeface="Calibri"/>
               </a:rPr>
-              <a:t>Claude Harness Engine v1.1.1   ·   Autonomous SDLC for Agentic Software</a:t>
+              <a:t>Claude Harness Engine v1.1.4   ·   Autonomous SDLC for Agentic Software</a:t>
             </a:r>
           </a:p>
         </p:txBody>
@@ -31945,7 +31949,2584 @@
                 </a:solidFill>
                 <a:latin typeface="Calibri"/>
               </a:rPr>
-              <a:t>30 / 30</a:t>
+              <a:t>30 / 34</a:t>
+            </a:r>
+          </a:p>
+        </p:txBody>
+      </p:sp>
+    </p:spTree>
+  </p:cSld>
+  <p:clrMapOvr>
+    <a:masterClrMapping/>
+  </p:clrMapOvr>
+</p:sld>
+</file>
+
+<file path=ppt/slides/slide31.xml><?xml version="1.0" encoding="utf-8"?>
+<p:sld xmlns:a="http://schemas.openxmlformats.org/drawingml/2006/main" xmlns:p="http://schemas.openxmlformats.org/presentationml/2006/main" xmlns:r="http://schemas.openxmlformats.org/officeDocument/2006/relationships">
+  <p:cSld>
+    <p:spTree>
+      <p:nvGrpSpPr>
+        <p:cNvPr id="1" name=""/>
+        <p:cNvGrpSpPr/>
+        <p:nvPr/>
+      </p:nvGrpSpPr>
+      <p:grpSpPr/>
+      <p:sp>
+        <p:nvSpPr>
+          <p:cNvPr id="2" name="TextBox 1"/>
+          <p:cNvSpPr txBox="1"/>
+          <p:nvPr/>
+        </p:nvSpPr>
+        <p:spPr>
+          <a:xfrm>
+            <a:off x="502920" y="320040"/>
+            <a:ext cx="11155680" cy="502920"/>
+          </a:xfrm>
+          <a:prstGeom prst="rect">
+            <a:avLst/>
+          </a:prstGeom>
+          <a:noFill/>
+        </p:spPr>
+        <p:txBody>
+          <a:bodyPr wrap="none">
+            <a:spAutoFit/>
+          </a:bodyPr>
+          <a:lstStyle/>
+          <a:p>
+            <a:pPr>
+              <a:defRPr sz="2700" b="1">
+                <a:solidFill>
+                  <a:srgbClr val="111827"/>
+                </a:solidFill>
+              </a:defRPr>
+            </a:pPr>
+            <a:r>
+              <a:t>Agent Factory: Tracker-Orchestrated Claude Harness</a:t>
+            </a:r>
+          </a:p>
+        </p:txBody>
+      </p:sp>
+      <p:sp>
+        <p:nvSpPr>
+          <p:cNvPr id="3" name="TextBox 2"/>
+          <p:cNvSpPr txBox="1"/>
+          <p:nvPr/>
+        </p:nvSpPr>
+        <p:spPr>
+          <a:xfrm>
+            <a:off x="530352" y="841248"/>
+            <a:ext cx="10789920" cy="301752"/>
+          </a:xfrm>
+          <a:prstGeom prst="rect">
+            <a:avLst/>
+          </a:prstGeom>
+          <a:noFill/>
+        </p:spPr>
+        <p:txBody>
+          <a:bodyPr wrap="none">
+            <a:spAutoFit/>
+          </a:bodyPr>
+          <a:lstStyle/>
+          <a:p>
+            <a:pPr>
+              <a:defRPr sz="1250">
+                <a:solidFill>
+                  <a:srgbClr val="4B5563"/>
+                </a:solidFill>
+              </a:defRPr>
+            </a:pPr>
+            <a:r>
+              <a:t>The optional flow keeps the scaffold local-first while letting Linear/Jira schedule independent story clusters.</a:t>
+            </a:r>
+          </a:p>
+        </p:txBody>
+      </p:sp>
+      <p:pic>
+        <p:nvPicPr>
+          <p:cNvPr id="4" name="Picture 3" descr="symphony_clone.png"/>
+          <p:cNvPicPr>
+            <a:picLocks noChangeAspect="1"/>
+          </p:cNvPicPr>
+          <p:nvPr/>
+        </p:nvPicPr>
+        <p:blipFill>
+          <a:blip r:embed="rId2"/>
+          <a:stretch>
+            <a:fillRect/>
+          </a:stretch>
+        </p:blipFill>
+        <p:spPr>
+          <a:xfrm>
+            <a:off x="685800" y="1143000"/>
+            <a:ext cx="10835640" cy="5945841"/>
+          </a:xfrm>
+          <a:prstGeom prst="rect">
+            <a:avLst/>
+          </a:prstGeom>
+        </p:spPr>
+      </p:pic>
+      <p:sp>
+        <p:nvSpPr>
+          <p:cNvPr id="5" name="Rounded Rectangle 4"/>
+          <p:cNvSpPr/>
+          <p:nvPr/>
+        </p:nvSpPr>
+        <p:spPr>
+          <a:xfrm>
+            <a:off x="1234440" y="5989320"/>
+            <a:ext cx="9738360" cy="320040"/>
+          </a:xfrm>
+          <a:prstGeom prst="roundRect">
+            <a:avLst/>
+          </a:prstGeom>
+          <a:solidFill>
+            <a:srgbClr val="FFFFFF"/>
+          </a:solidFill>
+          <a:ln w="15240">
+            <a:solidFill>
+              <a:srgbClr val="94A3B8"/>
+            </a:solidFill>
+          </a:ln>
+        </p:spPr>
+        <p:style>
+          <a:lnRef idx="1">
+            <a:schemeClr val="accent1"/>
+          </a:lnRef>
+          <a:fillRef idx="3">
+            <a:schemeClr val="accent1"/>
+          </a:fillRef>
+          <a:effectRef idx="2">
+            <a:schemeClr val="accent1"/>
+          </a:effectRef>
+          <a:fontRef idx="minor">
+            <a:schemeClr val="lt1"/>
+          </a:fontRef>
+        </p:style>
+        <p:txBody>
+          <a:bodyPr rtlCol="0" anchor="t" lIns="109728" rIns="109728" tIns="73152" bIns="73152"/>
+          <a:lstStyle/>
+          <a:p>
+            <a:pPr algn="ctr">
+              <a:defRPr sz="1300" b="1">
+                <a:solidFill>
+                  <a:srgbClr val="0F172A"/>
+                </a:solidFill>
+              </a:defRPr>
+            </a:pPr>
+            <a:r>
+              <a:t>Default path remains local-only. Tracker mode mirrors approved harness groups to Linear/Jira, then symphony_clone schedules eligible groups.</a:t>
+            </a:r>
+          </a:p>
+        </p:txBody>
+      </p:sp>
+      <p:sp>
+        <p:nvSpPr>
+          <p:cNvPr id="6" name="TextBox 5"/>
+          <p:cNvSpPr txBox="1"/>
+          <p:nvPr/>
+        </p:nvSpPr>
+        <p:spPr>
+          <a:xfrm>
+            <a:off x="411480" y="6446520"/>
+            <a:ext cx="6766560" cy="228600"/>
+          </a:xfrm>
+          <a:prstGeom prst="rect">
+            <a:avLst/>
+          </a:prstGeom>
+          <a:noFill/>
+        </p:spPr>
+        <p:txBody>
+          <a:bodyPr wrap="none">
+            <a:spAutoFit/>
+          </a:bodyPr>
+          <a:lstStyle/>
+          <a:p>
+            <a:pPr>
+              <a:defRPr sz="850">
+                <a:solidFill>
+                  <a:srgbClr val="566070"/>
+                </a:solidFill>
+              </a:defRPr>
+            </a:pPr>
+            <a:r>
+              <a:t>Claude Harness Engine v1.1.4   ·   Agent Factory + Tracker Orchestration</a:t>
+            </a:r>
+          </a:p>
+        </p:txBody>
+      </p:sp>
+      <p:sp>
+        <p:nvSpPr>
+          <p:cNvPr id="7" name="TextBox 6"/>
+          <p:cNvSpPr txBox="1"/>
+          <p:nvPr/>
+        </p:nvSpPr>
+        <p:spPr>
+          <a:xfrm>
+            <a:off x="10972800" y="6446520"/>
+            <a:ext cx="731520" cy="228600"/>
+          </a:xfrm>
+          <a:prstGeom prst="rect">
+            <a:avLst/>
+          </a:prstGeom>
+          <a:noFill/>
+        </p:spPr>
+        <p:txBody>
+          <a:bodyPr wrap="none">
+            <a:spAutoFit/>
+          </a:bodyPr>
+          <a:lstStyle/>
+          <a:p>
+            <a:pPr algn="r">
+              <a:defRPr sz="850">
+                <a:solidFill>
+                  <a:srgbClr val="566070"/>
+                </a:solidFill>
+              </a:defRPr>
+            </a:pPr>
+            <a:r>
+              <a:t>31 / 34</a:t>
+            </a:r>
+          </a:p>
+        </p:txBody>
+      </p:sp>
+    </p:spTree>
+  </p:cSld>
+  <p:clrMapOvr>
+    <a:masterClrMapping/>
+  </p:clrMapOvr>
+</p:sld>
+</file>
+
+<file path=ppt/slides/slide32.xml><?xml version="1.0" encoding="utf-8"?>
+<p:sld xmlns:a="http://schemas.openxmlformats.org/drawingml/2006/main" xmlns:p="http://schemas.openxmlformats.org/presentationml/2006/main" xmlns:r="http://schemas.openxmlformats.org/officeDocument/2006/relationships">
+  <p:cSld>
+    <p:spTree>
+      <p:nvGrpSpPr>
+        <p:cNvPr id="1" name=""/>
+        <p:cNvGrpSpPr/>
+        <p:nvPr/>
+      </p:nvGrpSpPr>
+      <p:grpSpPr/>
+      <p:sp>
+        <p:nvSpPr>
+          <p:cNvPr id="2" name="TextBox 1"/>
+          <p:cNvSpPr txBox="1"/>
+          <p:nvPr/>
+        </p:nvSpPr>
+        <p:spPr>
+          <a:xfrm>
+            <a:off x="502920" y="320040"/>
+            <a:ext cx="11155680" cy="502920"/>
+          </a:xfrm>
+          <a:prstGeom prst="rect">
+            <a:avLst/>
+          </a:prstGeom>
+          <a:noFill/>
+        </p:spPr>
+        <p:txBody>
+          <a:bodyPr wrap="none">
+            <a:spAutoFit/>
+          </a:bodyPr>
+          <a:lstStyle/>
+          <a:p>
+            <a:pPr>
+              <a:defRPr sz="2700" b="1">
+                <a:solidFill>
+                  <a:srgbClr val="111827"/>
+                </a:solidFill>
+              </a:defRPr>
+            </a:pPr>
+            <a:r>
+              <a:t>How symphony_clone Spins Up Claude Code Workspaces</a:t>
+            </a:r>
+          </a:p>
+        </p:txBody>
+      </p:sp>
+      <p:sp>
+        <p:nvSpPr>
+          <p:cNvPr id="3" name="TextBox 2"/>
+          <p:cNvSpPr txBox="1"/>
+          <p:nvPr/>
+        </p:nvSpPr>
+        <p:spPr>
+          <a:xfrm>
+            <a:off x="530352" y="841248"/>
+            <a:ext cx="10789920" cy="301752"/>
+          </a:xfrm>
+          <a:prstGeom prst="rect">
+            <a:avLst/>
+          </a:prstGeom>
+          <a:noFill/>
+        </p:spPr>
+        <p:txBody>
+          <a:bodyPr wrap="none">
+            <a:spAutoFit/>
+          </a:bodyPr>
+          <a:lstStyle/>
+          <a:p>
+            <a:pPr>
+              <a:defRPr sz="1250">
+                <a:solidFill>
+                  <a:srgbClr val="4B5563"/>
+                </a:solidFill>
+              </a:defRPr>
+            </a:pPr>
+            <a:r>
+              <a:t>One orchestrator process creates isolated agent runs from tracker-ready dependency groups.</a:t>
+            </a:r>
+          </a:p>
+        </p:txBody>
+      </p:sp>
+      <p:sp>
+        <p:nvSpPr>
+          <p:cNvPr id="4" name="Rounded Rectangle 3"/>
+          <p:cNvSpPr/>
+          <p:nvPr/>
+        </p:nvSpPr>
+        <p:spPr>
+          <a:xfrm>
+            <a:off x="502920" y="1417320"/>
+            <a:ext cx="1572768" cy="2743200"/>
+          </a:xfrm>
+          <a:prstGeom prst="roundRect">
+            <a:avLst/>
+          </a:prstGeom>
+          <a:solidFill>
+            <a:srgbClr val="F8FAFC"/>
+          </a:solidFill>
+          <a:ln w="15240">
+            <a:solidFill>
+              <a:srgbClr val="94A3B8"/>
+            </a:solidFill>
+          </a:ln>
+        </p:spPr>
+        <p:style>
+          <a:lnRef idx="1">
+            <a:schemeClr val="accent1"/>
+          </a:lnRef>
+          <a:fillRef idx="3">
+            <a:schemeClr val="accent1"/>
+          </a:fillRef>
+          <a:effectRef idx="2">
+            <a:schemeClr val="accent1"/>
+          </a:effectRef>
+          <a:fontRef idx="minor">
+            <a:schemeClr val="lt1"/>
+          </a:fontRef>
+        </p:style>
+        <p:txBody>
+          <a:bodyPr rtlCol="0" anchor="t" lIns="109728" rIns="109728" tIns="73152" bIns="73152"/>
+          <a:lstStyle/>
+          <a:p>
+            <a:pPr algn="ctr">
+              <a:defRPr sz="1300" b="1">
+                <a:solidFill>
+                  <a:srgbClr val="0F172A"/>
+                </a:solidFill>
+              </a:defRPr>
+            </a:pPr>
+            <a:r>
+              <a:t>1. Read config</a:t>
+            </a:r>
+          </a:p>
+          <a:p>
+            <a:pPr>
+              <a:spcBef>
+                <a:spcPts val="200"/>
+              </a:spcBef>
+              <a:defRPr sz="919">
+                <a:solidFill>
+                  <a:srgbClr val="334155"/>
+                </a:solidFill>
+              </a:defRPr>
+            </a:pPr>
+            <a:r>
+              <a:t>.env supplies Linear, GitHub, repo, labels, states, retry policy</a:t>
+            </a:r>
+          </a:p>
+        </p:txBody>
+      </p:sp>
+      <p:cxnSp>
+        <p:nvCxnSpPr>
+          <p:cNvPr id="5" name="Connector 4"/>
+          <p:cNvCxnSpPr/>
+          <p:nvPr/>
+        </p:nvCxnSpPr>
+        <p:spPr>
+          <a:xfrm>
+            <a:off x="2075688" y="2743200"/>
+            <a:ext cx="347472" cy="0"/>
+          </a:xfrm>
+          <a:prstGeom prst="line">
+            <a:avLst/>
+          </a:prstGeom>
+          <a:ln w="19050">
+            <a:solidFill>
+              <a:srgbClr val="475569"/>
+            </a:solidFill>
+          </a:ln>
+        </p:spPr>
+        <p:style>
+          <a:lnRef idx="2">
+            <a:schemeClr val="accent1"/>
+          </a:lnRef>
+          <a:fillRef idx="0">
+            <a:schemeClr val="accent1"/>
+          </a:fillRef>
+          <a:effectRef idx="1">
+            <a:schemeClr val="accent1"/>
+          </a:effectRef>
+          <a:fontRef idx="minor">
+            <a:schemeClr val="tx1"/>
+          </a:fontRef>
+        </p:style>
+      </p:cxnSp>
+      <p:sp>
+        <p:nvSpPr>
+          <p:cNvPr id="6" name="Rounded Rectangle 5"/>
+          <p:cNvSpPr/>
+          <p:nvPr/>
+        </p:nvSpPr>
+        <p:spPr>
+          <a:xfrm>
+            <a:off x="2423160" y="1417320"/>
+            <a:ext cx="1572768" cy="2743200"/>
+          </a:xfrm>
+          <a:prstGeom prst="roundRect">
+            <a:avLst/>
+          </a:prstGeom>
+          <a:solidFill>
+            <a:srgbClr val="FFFBEB"/>
+          </a:solidFill>
+          <a:ln w="15240">
+            <a:solidFill>
+              <a:srgbClr val="F59E0B"/>
+            </a:solidFill>
+          </a:ln>
+        </p:spPr>
+        <p:style>
+          <a:lnRef idx="1">
+            <a:schemeClr val="accent1"/>
+          </a:lnRef>
+          <a:fillRef idx="3">
+            <a:schemeClr val="accent1"/>
+          </a:fillRef>
+          <a:effectRef idx="2">
+            <a:schemeClr val="accent1"/>
+          </a:effectRef>
+          <a:fontRef idx="minor">
+            <a:schemeClr val="lt1"/>
+          </a:fontRef>
+        </p:style>
+        <p:txBody>
+          <a:bodyPr rtlCol="0" anchor="t" lIns="109728" rIns="109728" tIns="73152" bIns="73152"/>
+          <a:lstStyle/>
+          <a:p>
+            <a:pPr algn="ctr">
+              <a:defRPr sz="1300" b="1">
+                <a:solidFill>
+                  <a:srgbClr val="0F172A"/>
+                </a:solidFill>
+              </a:defRPr>
+            </a:pPr>
+            <a:r>
+              <a:t>2. Monitor tracker</a:t>
+            </a:r>
+          </a:p>
+          <a:p>
+            <a:pPr>
+              <a:spcBef>
+                <a:spcPts val="200"/>
+              </a:spcBef>
+              <a:defRPr sz="919">
+                <a:solidFill>
+                  <a:srgbClr val="334155"/>
+                </a:solidFill>
+              </a:defRPr>
+            </a:pPr>
+            <a:r>
+              <a:t>Poll Linear project for Ready + label and running states</a:t>
+            </a:r>
+          </a:p>
+        </p:txBody>
+      </p:sp>
+      <p:cxnSp>
+        <p:nvCxnSpPr>
+          <p:cNvPr id="7" name="Connector 6"/>
+          <p:cNvCxnSpPr/>
+          <p:nvPr/>
+        </p:nvCxnSpPr>
+        <p:spPr>
+          <a:xfrm>
+            <a:off x="3995928" y="2743200"/>
+            <a:ext cx="347472" cy="0"/>
+          </a:xfrm>
+          <a:prstGeom prst="line">
+            <a:avLst/>
+          </a:prstGeom>
+          <a:ln w="19050">
+            <a:solidFill>
+              <a:srgbClr val="475569"/>
+            </a:solidFill>
+          </a:ln>
+        </p:spPr>
+        <p:style>
+          <a:lnRef idx="2">
+            <a:schemeClr val="accent1"/>
+          </a:lnRef>
+          <a:fillRef idx="0">
+            <a:schemeClr val="accent1"/>
+          </a:fillRef>
+          <a:effectRef idx="1">
+            <a:schemeClr val="accent1"/>
+          </a:effectRef>
+          <a:fontRef idx="minor">
+            <a:schemeClr val="tx1"/>
+          </a:fontRef>
+        </p:style>
+      </p:cxnSp>
+      <p:sp>
+        <p:nvSpPr>
+          <p:cNvPr id="8" name="Rounded Rectangle 7"/>
+          <p:cNvSpPr/>
+          <p:nvPr/>
+        </p:nvSpPr>
+        <p:spPr>
+          <a:xfrm>
+            <a:off x="4343400" y="1417320"/>
+            <a:ext cx="1572768" cy="2743200"/>
+          </a:xfrm>
+          <a:prstGeom prst="roundRect">
+            <a:avLst/>
+          </a:prstGeom>
+          <a:solidFill>
+            <a:srgbClr val="F8FAFC"/>
+          </a:solidFill>
+          <a:ln w="15240">
+            <a:solidFill>
+              <a:srgbClr val="94A3B8"/>
+            </a:solidFill>
+          </a:ln>
+        </p:spPr>
+        <p:style>
+          <a:lnRef idx="1">
+            <a:schemeClr val="accent1"/>
+          </a:lnRef>
+          <a:fillRef idx="3">
+            <a:schemeClr val="accent1"/>
+          </a:fillRef>
+          <a:effectRef idx="2">
+            <a:schemeClr val="accent1"/>
+          </a:effectRef>
+          <a:fontRef idx="minor">
+            <a:schemeClr val="lt1"/>
+          </a:fontRef>
+        </p:style>
+        <p:txBody>
+          <a:bodyPr rtlCol="0" anchor="t" lIns="109728" rIns="109728" tIns="73152" bIns="73152"/>
+          <a:lstStyle/>
+          <a:p>
+            <a:pPr algn="ctr">
+              <a:defRPr sz="1300" b="1">
+                <a:solidFill>
+                  <a:srgbClr val="0F172A"/>
+                </a:solidFill>
+              </a:defRPr>
+            </a:pPr>
+            <a:r>
+              <a:t>3. Pick cluster</a:t>
+            </a:r>
+          </a:p>
+          <a:p>
+            <a:pPr>
+              <a:spcBef>
+                <a:spcPts val="200"/>
+              </a:spcBef>
+              <a:defRPr sz="919">
+                <a:solidFill>
+                  <a:srgbClr val="334155"/>
+                </a:solidFill>
+              </a:defRPr>
+            </a:pPr>
+            <a:r>
+              <a:t>Filter blockers using dependency links and terminal states</a:t>
+            </a:r>
+          </a:p>
+        </p:txBody>
+      </p:sp>
+      <p:cxnSp>
+        <p:nvCxnSpPr>
+          <p:cNvPr id="9" name="Connector 8"/>
+          <p:cNvCxnSpPr/>
+          <p:nvPr/>
+        </p:nvCxnSpPr>
+        <p:spPr>
+          <a:xfrm>
+            <a:off x="5916168" y="2743200"/>
+            <a:ext cx="347472" cy="0"/>
+          </a:xfrm>
+          <a:prstGeom prst="line">
+            <a:avLst/>
+          </a:prstGeom>
+          <a:ln w="19050">
+            <a:solidFill>
+              <a:srgbClr val="475569"/>
+            </a:solidFill>
+          </a:ln>
+        </p:spPr>
+        <p:style>
+          <a:lnRef idx="2">
+            <a:schemeClr val="accent1"/>
+          </a:lnRef>
+          <a:fillRef idx="0">
+            <a:schemeClr val="accent1"/>
+          </a:fillRef>
+          <a:effectRef idx="1">
+            <a:schemeClr val="accent1"/>
+          </a:effectRef>
+          <a:fontRef idx="minor">
+            <a:schemeClr val="tx1"/>
+          </a:fontRef>
+        </p:style>
+      </p:cxnSp>
+      <p:sp>
+        <p:nvSpPr>
+          <p:cNvPr id="10" name="Rounded Rectangle 9"/>
+          <p:cNvSpPr/>
+          <p:nvPr/>
+        </p:nvSpPr>
+        <p:spPr>
+          <a:xfrm>
+            <a:off x="6263640" y="1417320"/>
+            <a:ext cx="1572768" cy="2743200"/>
+          </a:xfrm>
+          <a:prstGeom prst="roundRect">
+            <a:avLst/>
+          </a:prstGeom>
+          <a:solidFill>
+            <a:srgbClr val="FFFBEB"/>
+          </a:solidFill>
+          <a:ln w="15240">
+            <a:solidFill>
+              <a:srgbClr val="F59E0B"/>
+            </a:solidFill>
+          </a:ln>
+        </p:spPr>
+        <p:style>
+          <a:lnRef idx="1">
+            <a:schemeClr val="accent1"/>
+          </a:lnRef>
+          <a:fillRef idx="3">
+            <a:schemeClr val="accent1"/>
+          </a:fillRef>
+          <a:effectRef idx="2">
+            <a:schemeClr val="accent1"/>
+          </a:effectRef>
+          <a:fontRef idx="minor">
+            <a:schemeClr val="lt1"/>
+          </a:fontRef>
+        </p:style>
+        <p:txBody>
+          <a:bodyPr rtlCol="0" anchor="t" lIns="109728" rIns="109728" tIns="73152" bIns="73152"/>
+          <a:lstStyle/>
+          <a:p>
+            <a:pPr algn="ctr">
+              <a:defRPr sz="1300" b="1">
+                <a:solidFill>
+                  <a:srgbClr val="0F172A"/>
+                </a:solidFill>
+              </a:defRPr>
+            </a:pPr>
+            <a:r>
+              <a:t>4. Claim work</a:t>
+            </a:r>
+          </a:p>
+          <a:p>
+            <a:pPr>
+              <a:spcBef>
+                <a:spcPts val="200"/>
+              </a:spcBef>
+              <a:defRPr sz="919">
+                <a:solidFill>
+                  <a:srgbClr val="334155"/>
+                </a:solidFill>
+              </a:defRPr>
+            </a:pPr>
+            <a:r>
+              <a:t>Move issue to In Progress and add claim comment</a:t>
+            </a:r>
+          </a:p>
+        </p:txBody>
+      </p:sp>
+      <p:cxnSp>
+        <p:nvCxnSpPr>
+          <p:cNvPr id="11" name="Connector 10"/>
+          <p:cNvCxnSpPr/>
+          <p:nvPr/>
+        </p:nvCxnSpPr>
+        <p:spPr>
+          <a:xfrm>
+            <a:off x="7836408" y="2743200"/>
+            <a:ext cx="347471" cy="0"/>
+          </a:xfrm>
+          <a:prstGeom prst="line">
+            <a:avLst/>
+          </a:prstGeom>
+          <a:ln w="19050">
+            <a:solidFill>
+              <a:srgbClr val="475569"/>
+            </a:solidFill>
+          </a:ln>
+        </p:spPr>
+        <p:style>
+          <a:lnRef idx="2">
+            <a:schemeClr val="accent1"/>
+          </a:lnRef>
+          <a:fillRef idx="0">
+            <a:schemeClr val="accent1"/>
+          </a:fillRef>
+          <a:effectRef idx="1">
+            <a:schemeClr val="accent1"/>
+          </a:effectRef>
+          <a:fontRef idx="minor">
+            <a:schemeClr val="tx1"/>
+          </a:fontRef>
+        </p:style>
+      </p:cxnSp>
+      <p:sp>
+        <p:nvSpPr>
+          <p:cNvPr id="12" name="Rounded Rectangle 11"/>
+          <p:cNvSpPr/>
+          <p:nvPr/>
+        </p:nvSpPr>
+        <p:spPr>
+          <a:xfrm>
+            <a:off x="8183879" y="1417320"/>
+            <a:ext cx="1572768" cy="2743200"/>
+          </a:xfrm>
+          <a:prstGeom prst="roundRect">
+            <a:avLst/>
+          </a:prstGeom>
+          <a:solidFill>
+            <a:srgbClr val="F8FAFC"/>
+          </a:solidFill>
+          <a:ln w="15240">
+            <a:solidFill>
+              <a:srgbClr val="94A3B8"/>
+            </a:solidFill>
+          </a:ln>
+        </p:spPr>
+        <p:style>
+          <a:lnRef idx="1">
+            <a:schemeClr val="accent1"/>
+          </a:lnRef>
+          <a:fillRef idx="3">
+            <a:schemeClr val="accent1"/>
+          </a:fillRef>
+          <a:effectRef idx="2">
+            <a:schemeClr val="accent1"/>
+          </a:effectRef>
+          <a:fontRef idx="minor">
+            <a:schemeClr val="lt1"/>
+          </a:fontRef>
+        </p:style>
+        <p:txBody>
+          <a:bodyPr rtlCol="0" anchor="t" lIns="109728" rIns="109728" tIns="73152" bIns="73152"/>
+          <a:lstStyle/>
+          <a:p>
+            <a:pPr algn="ctr">
+              <a:defRPr sz="1300" b="1">
+                <a:solidFill>
+                  <a:srgbClr val="0F172A"/>
+                </a:solidFill>
+              </a:defRPr>
+            </a:pPr>
+            <a:r>
+              <a:t>5. Launch Claude</a:t>
+            </a:r>
+          </a:p>
+          <a:p>
+            <a:pPr>
+              <a:spcBef>
+                <a:spcPts val="200"/>
+              </a:spcBef>
+              <a:defRPr sz="919">
+                <a:solidFill>
+                  <a:srgbClr val="334155"/>
+                </a:solidFill>
+              </a:defRPr>
+            </a:pPr>
+            <a:r>
+              <a:t>Clone repo, create agent/&lt;key&gt;, run claude --print prompt</a:t>
+            </a:r>
+          </a:p>
+        </p:txBody>
+      </p:sp>
+      <p:cxnSp>
+        <p:nvCxnSpPr>
+          <p:cNvPr id="13" name="Connector 12"/>
+          <p:cNvCxnSpPr/>
+          <p:nvPr/>
+        </p:nvCxnSpPr>
+        <p:spPr>
+          <a:xfrm>
+            <a:off x="9756648" y="2743200"/>
+            <a:ext cx="347472" cy="0"/>
+          </a:xfrm>
+          <a:prstGeom prst="line">
+            <a:avLst/>
+          </a:prstGeom>
+          <a:ln w="19050">
+            <a:solidFill>
+              <a:srgbClr val="475569"/>
+            </a:solidFill>
+          </a:ln>
+        </p:spPr>
+        <p:style>
+          <a:lnRef idx="2">
+            <a:schemeClr val="accent1"/>
+          </a:lnRef>
+          <a:fillRef idx="0">
+            <a:schemeClr val="accent1"/>
+          </a:fillRef>
+          <a:effectRef idx="1">
+            <a:schemeClr val="accent1"/>
+          </a:effectRef>
+          <a:fontRef idx="minor">
+            <a:schemeClr val="tx1"/>
+          </a:fontRef>
+        </p:style>
+      </p:cxnSp>
+      <p:sp>
+        <p:nvSpPr>
+          <p:cNvPr id="14" name="Rounded Rectangle 13"/>
+          <p:cNvSpPr/>
+          <p:nvPr/>
+        </p:nvSpPr>
+        <p:spPr>
+          <a:xfrm>
+            <a:off x="10104120" y="1417320"/>
+            <a:ext cx="1572768" cy="2743200"/>
+          </a:xfrm>
+          <a:prstGeom prst="roundRect">
+            <a:avLst/>
+          </a:prstGeom>
+          <a:solidFill>
+            <a:srgbClr val="FFFBEB"/>
+          </a:solidFill>
+          <a:ln w="15240">
+            <a:solidFill>
+              <a:srgbClr val="F59E0B"/>
+            </a:solidFill>
+          </a:ln>
+        </p:spPr>
+        <p:style>
+          <a:lnRef idx="1">
+            <a:schemeClr val="accent1"/>
+          </a:lnRef>
+          <a:fillRef idx="3">
+            <a:schemeClr val="accent1"/>
+          </a:fillRef>
+          <a:effectRef idx="2">
+            <a:schemeClr val="accent1"/>
+          </a:effectRef>
+          <a:fontRef idx="minor">
+            <a:schemeClr val="lt1"/>
+          </a:fontRef>
+        </p:style>
+        <p:txBody>
+          <a:bodyPr rtlCol="0" anchor="t" lIns="109728" rIns="109728" tIns="73152" bIns="73152"/>
+          <a:lstStyle/>
+          <a:p>
+            <a:pPr algn="ctr">
+              <a:defRPr sz="1300" b="1">
+                <a:solidFill>
+                  <a:srgbClr val="0F172A"/>
+                </a:solidFill>
+              </a:defRPr>
+            </a:pPr>
+            <a:r>
+              <a:t>6. Deliver proof</a:t>
+            </a:r>
+          </a:p>
+          <a:p>
+            <a:pPr>
+              <a:spcBef>
+                <a:spcPts val="200"/>
+              </a:spcBef>
+              <a:defRPr sz="919">
+                <a:solidFill>
+                  <a:srgbClr val="334155"/>
+                </a:solidFill>
+              </a:defRPr>
+            </a:pPr>
+            <a:r>
+              <a:t>Read result.json, push branch, open PR, comment, move review</a:t>
+            </a:r>
+          </a:p>
+        </p:txBody>
+      </p:sp>
+      <p:sp>
+        <p:nvSpPr>
+          <p:cNvPr id="15" name="Rounded Rectangle 14"/>
+          <p:cNvSpPr/>
+          <p:nvPr/>
+        </p:nvSpPr>
+        <p:spPr>
+          <a:xfrm>
+            <a:off x="914400" y="4800600"/>
+            <a:ext cx="3108960" cy="777240"/>
+          </a:xfrm>
+          <a:prstGeom prst="roundRect">
+            <a:avLst/>
+          </a:prstGeom>
+          <a:solidFill>
+            <a:srgbClr val="EFF6FF"/>
+          </a:solidFill>
+          <a:ln w="15240">
+            <a:solidFill>
+              <a:srgbClr val="60A5FA"/>
+            </a:solidFill>
+          </a:ln>
+        </p:spPr>
+        <p:style>
+          <a:lnRef idx="1">
+            <a:schemeClr val="accent1"/>
+          </a:lnRef>
+          <a:fillRef idx="3">
+            <a:schemeClr val="accent1"/>
+          </a:fillRef>
+          <a:effectRef idx="2">
+            <a:schemeClr val="accent1"/>
+          </a:effectRef>
+          <a:fontRef idx="minor">
+            <a:schemeClr val="lt1"/>
+          </a:fontRef>
+        </p:style>
+        <p:txBody>
+          <a:bodyPr rtlCol="0" anchor="t" lIns="109728" rIns="109728" tIns="73152" bIns="73152"/>
+          <a:lstStyle/>
+          <a:p>
+            <a:pPr algn="ctr">
+              <a:defRPr sz="1300" b="1">
+                <a:solidFill>
+                  <a:srgbClr val="0F172A"/>
+                </a:solidFill>
+              </a:defRPr>
+            </a:pPr>
+            <a:r>
+              <a:t>Instance boundary</a:t>
+            </a:r>
+          </a:p>
+          <a:p>
+            <a:pPr>
+              <a:spcBef>
+                <a:spcPts val="200"/>
+              </a:spcBef>
+              <a:defRPr sz="1000">
+                <a:solidFill>
+                  <a:srgbClr val="334155"/>
+                </a:solidFill>
+              </a:defRPr>
+            </a:pPr>
+            <a:r>
+              <a:t>Each Linear issue maps to one workspace under WORKSPACE_ROOT/&lt;issue-key&gt;.</a:t>
+            </a:r>
+          </a:p>
+        </p:txBody>
+      </p:sp>
+      <p:sp>
+        <p:nvSpPr>
+          <p:cNvPr id="16" name="Rounded Rectangle 15"/>
+          <p:cNvSpPr/>
+          <p:nvPr/>
+        </p:nvSpPr>
+        <p:spPr>
+          <a:xfrm>
+            <a:off x="4526280" y="4800600"/>
+            <a:ext cx="3108960" cy="777240"/>
+          </a:xfrm>
+          <a:prstGeom prst="roundRect">
+            <a:avLst/>
+          </a:prstGeom>
+          <a:solidFill>
+            <a:srgbClr val="F5F3FF"/>
+          </a:solidFill>
+          <a:ln w="15240">
+            <a:solidFill>
+              <a:srgbClr val="A78BFA"/>
+            </a:solidFill>
+          </a:ln>
+        </p:spPr>
+        <p:style>
+          <a:lnRef idx="1">
+            <a:schemeClr val="accent1"/>
+          </a:lnRef>
+          <a:fillRef idx="3">
+            <a:schemeClr val="accent1"/>
+          </a:fillRef>
+          <a:effectRef idx="2">
+            <a:schemeClr val="accent1"/>
+          </a:effectRef>
+          <a:fontRef idx="minor">
+            <a:schemeClr val="lt1"/>
+          </a:fontRef>
+        </p:style>
+        <p:txBody>
+          <a:bodyPr rtlCol="0" anchor="t" lIns="109728" rIns="109728" tIns="73152" bIns="73152"/>
+          <a:lstStyle/>
+          <a:p>
+            <a:pPr algn="ctr">
+              <a:defRPr sz="1300" b="1">
+                <a:solidFill>
+                  <a:srgbClr val="0F172A"/>
+                </a:solidFill>
+              </a:defRPr>
+            </a:pPr>
+            <a:r>
+              <a:t>Agent team boundary</a:t>
+            </a:r>
+          </a:p>
+          <a:p>
+            <a:pPr>
+              <a:spcBef>
+                <a:spcPts val="200"/>
+              </a:spcBef>
+              <a:defRPr sz="1000">
+                <a:solidFill>
+                  <a:srgbClr val="334155"/>
+                </a:solidFill>
+              </a:defRPr>
+            </a:pPr>
+            <a:r>
+              <a:t>Inside the workspace, /auto --group A creates story-level teammates and verifier loops.</a:t>
+            </a:r>
+          </a:p>
+        </p:txBody>
+      </p:sp>
+      <p:sp>
+        <p:nvSpPr>
+          <p:cNvPr id="17" name="Rounded Rectangle 16"/>
+          <p:cNvSpPr/>
+          <p:nvPr/>
+        </p:nvSpPr>
+        <p:spPr>
+          <a:xfrm>
+            <a:off x="8138160" y="4800600"/>
+            <a:ext cx="3108960" cy="777240"/>
+          </a:xfrm>
+          <a:prstGeom prst="roundRect">
+            <a:avLst/>
+          </a:prstGeom>
+          <a:solidFill>
+            <a:srgbClr val="F0FDF4"/>
+          </a:solidFill>
+          <a:ln w="15240">
+            <a:solidFill>
+              <a:srgbClr val="4ADE80"/>
+            </a:solidFill>
+          </a:ln>
+        </p:spPr>
+        <p:style>
+          <a:lnRef idx="1">
+            <a:schemeClr val="accent1"/>
+          </a:lnRef>
+          <a:fillRef idx="3">
+            <a:schemeClr val="accent1"/>
+          </a:fillRef>
+          <a:effectRef idx="2">
+            <a:schemeClr val="accent1"/>
+          </a:effectRef>
+          <a:fontRef idx="minor">
+            <a:schemeClr val="lt1"/>
+          </a:fontRef>
+        </p:style>
+        <p:txBody>
+          <a:bodyPr rtlCol="0" anchor="t" lIns="109728" rIns="109728" tIns="73152" bIns="73152"/>
+          <a:lstStyle/>
+          <a:p>
+            <a:pPr algn="ctr">
+              <a:defRPr sz="1300" b="1">
+                <a:solidFill>
+                  <a:srgbClr val="0F172A"/>
+                </a:solidFill>
+              </a:defRPr>
+            </a:pPr>
+            <a:r>
+              <a:t>Delivery boundary</a:t>
+            </a:r>
+          </a:p>
+          <a:p>
+            <a:pPr>
+              <a:spcBef>
+                <a:spcPts val="200"/>
+              </a:spcBef>
+              <a:defRPr sz="1000">
+                <a:solidFill>
+                  <a:srgbClr val="334155"/>
+                </a:solidFill>
+              </a:defRPr>
+            </a:pPr>
+            <a:r>
+              <a:t>The orchestrator can create PRs, but humans still review, merge, and mark Done.</a:t>
+            </a:r>
+          </a:p>
+        </p:txBody>
+      </p:sp>
+      <p:sp>
+        <p:nvSpPr>
+          <p:cNvPr id="18" name="TextBox 17"/>
+          <p:cNvSpPr txBox="1"/>
+          <p:nvPr/>
+        </p:nvSpPr>
+        <p:spPr>
+          <a:xfrm>
+            <a:off x="411480" y="6446520"/>
+            <a:ext cx="6766560" cy="228600"/>
+          </a:xfrm>
+          <a:prstGeom prst="rect">
+            <a:avLst/>
+          </a:prstGeom>
+          <a:noFill/>
+        </p:spPr>
+        <p:txBody>
+          <a:bodyPr wrap="none">
+            <a:spAutoFit/>
+          </a:bodyPr>
+          <a:lstStyle/>
+          <a:p>
+            <a:pPr>
+              <a:defRPr sz="850">
+                <a:solidFill>
+                  <a:srgbClr val="566070"/>
+                </a:solidFill>
+              </a:defRPr>
+            </a:pPr>
+            <a:r>
+              <a:t>Claude Harness Engine v1.1.4   ·   Agent Factory + Tracker Orchestration</a:t>
+            </a:r>
+          </a:p>
+        </p:txBody>
+      </p:sp>
+      <p:sp>
+        <p:nvSpPr>
+          <p:cNvPr id="19" name="TextBox 18"/>
+          <p:cNvSpPr txBox="1"/>
+          <p:nvPr/>
+        </p:nvSpPr>
+        <p:spPr>
+          <a:xfrm>
+            <a:off x="10972800" y="6446520"/>
+            <a:ext cx="731520" cy="228600"/>
+          </a:xfrm>
+          <a:prstGeom prst="rect">
+            <a:avLst/>
+          </a:prstGeom>
+          <a:noFill/>
+        </p:spPr>
+        <p:txBody>
+          <a:bodyPr wrap="none">
+            <a:spAutoFit/>
+          </a:bodyPr>
+          <a:lstStyle/>
+          <a:p>
+            <a:pPr algn="r">
+              <a:defRPr sz="850">
+                <a:solidFill>
+                  <a:srgbClr val="566070"/>
+                </a:solidFill>
+              </a:defRPr>
+            </a:pPr>
+            <a:r>
+              <a:t>32 / 34</a:t>
+            </a:r>
+          </a:p>
+        </p:txBody>
+      </p:sp>
+    </p:spTree>
+  </p:cSld>
+  <p:clrMapOvr>
+    <a:masterClrMapping/>
+  </p:clrMapOvr>
+</p:sld>
+</file>
+
+<file path=ppt/slides/slide33.xml><?xml version="1.0" encoding="utf-8"?>
+<p:sld xmlns:a="http://schemas.openxmlformats.org/drawingml/2006/main" xmlns:p="http://schemas.openxmlformats.org/presentationml/2006/main" xmlns:r="http://schemas.openxmlformats.org/officeDocument/2006/relationships">
+  <p:cSld>
+    <p:spTree>
+      <p:nvGrpSpPr>
+        <p:cNvPr id="1" name=""/>
+        <p:cNvGrpSpPr/>
+        <p:nvPr/>
+      </p:nvGrpSpPr>
+      <p:grpSpPr/>
+      <p:sp>
+        <p:nvSpPr>
+          <p:cNvPr id="2" name="TextBox 1"/>
+          <p:cNvSpPr txBox="1"/>
+          <p:nvPr/>
+        </p:nvSpPr>
+        <p:spPr>
+          <a:xfrm>
+            <a:off x="502920" y="320040"/>
+            <a:ext cx="11155680" cy="502920"/>
+          </a:xfrm>
+          <a:prstGeom prst="rect">
+            <a:avLst/>
+          </a:prstGeom>
+          <a:noFill/>
+        </p:spPr>
+        <p:txBody>
+          <a:bodyPr wrap="none">
+            <a:spAutoFit/>
+          </a:bodyPr>
+          <a:lstStyle/>
+          <a:p>
+            <a:pPr>
+              <a:defRPr sz="2700" b="1">
+                <a:solidFill>
+                  <a:srgbClr val="111827"/>
+                </a:solidFill>
+              </a:defRPr>
+            </a:pPr>
+            <a:r>
+              <a:t>Packaging Contract: What Gets Copied vs What Runs Outside</a:t>
+            </a:r>
+          </a:p>
+        </p:txBody>
+      </p:sp>
+      <p:sp>
+        <p:nvSpPr>
+          <p:cNvPr id="3" name="TextBox 2"/>
+          <p:cNvSpPr txBox="1"/>
+          <p:nvPr/>
+        </p:nvSpPr>
+        <p:spPr>
+          <a:xfrm>
+            <a:off x="530352" y="841248"/>
+            <a:ext cx="10789920" cy="301752"/>
+          </a:xfrm>
+          <a:prstGeom prst="rect">
+            <a:avLst/>
+          </a:prstGeom>
+          <a:noFill/>
+        </p:spPr>
+        <p:txBody>
+          <a:bodyPr wrap="none">
+            <a:spAutoFit/>
+          </a:bodyPr>
+          <a:lstStyle/>
+          <a:p>
+            <a:pPr>
+              <a:defRPr sz="1250">
+                <a:solidFill>
+                  <a:srgbClr val="4B5563"/>
+                </a:solidFill>
+              </a:defRPr>
+            </a:pPr>
+            <a:r>
+              <a:t>The scaffold defines the work contract; symphony_clone consumes it as infrastructure.</a:t>
+            </a:r>
+          </a:p>
+        </p:txBody>
+      </p:sp>
+      <p:sp>
+        <p:nvSpPr>
+          <p:cNvPr id="4" name="Rounded Rectangle 3"/>
+          <p:cNvSpPr/>
+          <p:nvPr/>
+        </p:nvSpPr>
+        <p:spPr>
+          <a:xfrm>
+            <a:off x="502920" y="1417320"/>
+            <a:ext cx="2514600" cy="4297680"/>
+          </a:xfrm>
+          <a:prstGeom prst="roundRect">
+            <a:avLst/>
+          </a:prstGeom>
+          <a:solidFill>
+            <a:srgbClr val="EFF6FF"/>
+          </a:solidFill>
+          <a:ln w="15240">
+            <a:solidFill>
+              <a:srgbClr val="3B82F6"/>
+            </a:solidFill>
+          </a:ln>
+        </p:spPr>
+        <p:style>
+          <a:lnRef idx="1">
+            <a:schemeClr val="accent1"/>
+          </a:lnRef>
+          <a:fillRef idx="3">
+            <a:schemeClr val="accent1"/>
+          </a:fillRef>
+          <a:effectRef idx="2">
+            <a:schemeClr val="accent1"/>
+          </a:effectRef>
+          <a:fontRef idx="minor">
+            <a:schemeClr val="lt1"/>
+          </a:fontRef>
+        </p:style>
+        <p:txBody>
+          <a:bodyPr rtlCol="0" anchor="t" lIns="109728" rIns="109728" tIns="73152" bIns="73152"/>
+          <a:lstStyle/>
+          <a:p>
+            <a:pPr algn="ctr">
+              <a:defRPr sz="1300" b="1">
+                <a:solidFill>
+                  <a:srgbClr val="0F172A"/>
+                </a:solidFill>
+              </a:defRPr>
+            </a:pPr>
+            <a:r>
+              <a:t>Scaffolded target repo</a:t>
+            </a:r>
+          </a:p>
+          <a:p>
+            <a:pPr>
+              <a:spcBef>
+                <a:spcPts val="400"/>
+              </a:spcBef>
+              <a:defRPr sz="1050">
+                <a:solidFill>
+                  <a:srgbClr val="334155"/>
+                </a:solidFill>
+              </a:defRPr>
+            </a:pPr>
+            <a:r>
+              <a:t>.claude/ skills, agents, hooks</a:t>
+            </a:r>
+          </a:p>
+          <a:p>
+            <a:pPr>
+              <a:spcBef>
+                <a:spcPts val="400"/>
+              </a:spcBef>
+              <a:defRPr sz="1050">
+                <a:solidFill>
+                  <a:srgbClr val="334155"/>
+                </a:solidFill>
+              </a:defRPr>
+            </a:pPr>
+            <a:r>
+              <a:t>CLAUDE.md + design.md</a:t>
+            </a:r>
+          </a:p>
+          <a:p>
+            <a:pPr>
+              <a:spcBef>
+                <a:spcPts val="400"/>
+              </a:spcBef>
+              <a:defRPr sz="1050">
+                <a:solidFill>
+                  <a:srgbClr val="334155"/>
+                </a:solidFill>
+              </a:defRPr>
+            </a:pPr>
+            <a:r>
+              <a:t>specs/stories + dependency graph</a:t>
+            </a:r>
+          </a:p>
+          <a:p>
+            <a:pPr>
+              <a:spcBef>
+                <a:spcPts val="400"/>
+              </a:spcBef>
+              <a:defRPr sz="1050">
+                <a:solidFill>
+                  <a:srgbClr val="334155"/>
+                </a:solidFill>
+              </a:defRPr>
+            </a:pPr>
+            <a:r>
+              <a:t>features.json + component-map</a:t>
+            </a:r>
+          </a:p>
+          <a:p>
+            <a:pPr>
+              <a:spcBef>
+                <a:spcPts val="400"/>
+              </a:spcBef>
+              <a:defRPr sz="1050">
+                <a:solidFill>
+                  <a:srgbClr val="334155"/>
+                </a:solidFill>
+              </a:defRPr>
+            </a:pPr>
+            <a:r>
+              <a:t>tracker-config only if enabled</a:t>
+            </a:r>
+          </a:p>
+        </p:txBody>
+      </p:sp>
+      <p:sp>
+        <p:nvSpPr>
+          <p:cNvPr id="5" name="Rounded Rectangle 4"/>
+          <p:cNvSpPr/>
+          <p:nvPr/>
+        </p:nvSpPr>
+        <p:spPr>
+          <a:xfrm>
+            <a:off x="3383280" y="1417320"/>
+            <a:ext cx="2514600" cy="4297680"/>
+          </a:xfrm>
+          <a:prstGeom prst="roundRect">
+            <a:avLst/>
+          </a:prstGeom>
+          <a:solidFill>
+            <a:srgbClr val="F0FDF4"/>
+          </a:solidFill>
+          <a:ln w="15240">
+            <a:solidFill>
+              <a:srgbClr val="22C55E"/>
+            </a:solidFill>
+          </a:ln>
+        </p:spPr>
+        <p:style>
+          <a:lnRef idx="1">
+            <a:schemeClr val="accent1"/>
+          </a:lnRef>
+          <a:fillRef idx="3">
+            <a:schemeClr val="accent1"/>
+          </a:fillRef>
+          <a:effectRef idx="2">
+            <a:schemeClr val="accent1"/>
+          </a:effectRef>
+          <a:fontRef idx="minor">
+            <a:schemeClr val="lt1"/>
+          </a:fontRef>
+        </p:style>
+        <p:txBody>
+          <a:bodyPr rtlCol="0" anchor="t" lIns="109728" rIns="109728" tIns="73152" bIns="73152"/>
+          <a:lstStyle/>
+          <a:p>
+            <a:pPr algn="ctr">
+              <a:defRPr sz="1300" b="1">
+                <a:solidFill>
+                  <a:srgbClr val="0F172A"/>
+                </a:solidFill>
+              </a:defRPr>
+            </a:pPr>
+            <a:r>
+              <a:t>Tracker system</a:t>
+            </a:r>
+          </a:p>
+          <a:p>
+            <a:pPr>
+              <a:spcBef>
+                <a:spcPts val="400"/>
+              </a:spcBef>
+              <a:defRPr sz="1050">
+                <a:solidFill>
+                  <a:srgbClr val="334155"/>
+                </a:solidFill>
+              </a:defRPr>
+            </a:pPr>
+            <a:r>
+              <a:t>Linear/Jira group issues</a:t>
+            </a:r>
+          </a:p>
+          <a:p>
+            <a:pPr>
+              <a:spcBef>
+                <a:spcPts val="400"/>
+              </a:spcBef>
+              <a:defRPr sz="1050">
+                <a:solidFill>
+                  <a:srgbClr val="334155"/>
+                </a:solidFill>
+              </a:defRPr>
+            </a:pPr>
+            <a:r>
+              <a:t>ready label + workflow state</a:t>
+            </a:r>
+          </a:p>
+          <a:p>
+            <a:pPr>
+              <a:spcBef>
+                <a:spcPts val="400"/>
+              </a:spcBef>
+              <a:defRPr sz="1050">
+                <a:solidFill>
+                  <a:srgbClr val="334155"/>
+                </a:solidFill>
+              </a:defRPr>
+            </a:pPr>
+            <a:r>
+              <a:t>blocker relationships</a:t>
+            </a:r>
+          </a:p>
+          <a:p>
+            <a:pPr>
+              <a:spcBef>
+                <a:spcPts val="400"/>
+              </a:spcBef>
+              <a:defRPr sz="1050">
+                <a:solidFill>
+                  <a:srgbClr val="334155"/>
+                </a:solidFill>
+              </a:defRPr>
+            </a:pPr>
+            <a:r>
+              <a:t>proof comments + PR links</a:t>
+            </a:r>
+          </a:p>
+          <a:p>
+            <a:pPr>
+              <a:spcBef>
+                <a:spcPts val="400"/>
+              </a:spcBef>
+              <a:defRPr sz="1050">
+                <a:solidFill>
+                  <a:srgbClr val="334155"/>
+                </a:solidFill>
+              </a:defRPr>
+            </a:pPr>
+            <a:r>
+              <a:t>Human Review visible queue</a:t>
+            </a:r>
+          </a:p>
+        </p:txBody>
+      </p:sp>
+      <p:sp>
+        <p:nvSpPr>
+          <p:cNvPr id="6" name="Rounded Rectangle 5"/>
+          <p:cNvSpPr/>
+          <p:nvPr/>
+        </p:nvSpPr>
+        <p:spPr>
+          <a:xfrm>
+            <a:off x="6263640" y="1417320"/>
+            <a:ext cx="2514600" cy="4297680"/>
+          </a:xfrm>
+          <a:prstGeom prst="roundRect">
+            <a:avLst/>
+          </a:prstGeom>
+          <a:solidFill>
+            <a:srgbClr val="FFFBEB"/>
+          </a:solidFill>
+          <a:ln w="15240">
+            <a:solidFill>
+              <a:srgbClr val="F59E0B"/>
+            </a:solidFill>
+          </a:ln>
+        </p:spPr>
+        <p:style>
+          <a:lnRef idx="1">
+            <a:schemeClr val="accent1"/>
+          </a:lnRef>
+          <a:fillRef idx="3">
+            <a:schemeClr val="accent1"/>
+          </a:fillRef>
+          <a:effectRef idx="2">
+            <a:schemeClr val="accent1"/>
+          </a:effectRef>
+          <a:fontRef idx="minor">
+            <a:schemeClr val="lt1"/>
+          </a:fontRef>
+        </p:style>
+        <p:txBody>
+          <a:bodyPr rtlCol="0" anchor="t" lIns="109728" rIns="109728" tIns="73152" bIns="73152"/>
+          <a:lstStyle/>
+          <a:p>
+            <a:pPr algn="ctr">
+              <a:defRPr sz="1300" b="1">
+                <a:solidFill>
+                  <a:srgbClr val="0F172A"/>
+                </a:solidFill>
+              </a:defRPr>
+            </a:pPr>
+            <a:r>
+              <a:t>symphony_clone runtime</a:t>
+            </a:r>
+          </a:p>
+          <a:p>
+            <a:pPr>
+              <a:spcBef>
+                <a:spcPts val="400"/>
+              </a:spcBef>
+              <a:defRPr sz="1050">
+                <a:solidFill>
+                  <a:srgbClr val="334155"/>
+                </a:solidFill>
+              </a:defRPr>
+            </a:pPr>
+            <a:r>
+              <a:t>Docker or local Node process</a:t>
+            </a:r>
+          </a:p>
+          <a:p>
+            <a:pPr>
+              <a:spcBef>
+                <a:spcPts val="400"/>
+              </a:spcBef>
+              <a:defRPr sz="1050">
+                <a:solidFill>
+                  <a:srgbClr val="334155"/>
+                </a:solidFill>
+              </a:defRPr>
+            </a:pPr>
+            <a:r>
+              <a:t>StateStore + JSONL logs</a:t>
+            </a:r>
+          </a:p>
+          <a:p>
+            <a:pPr>
+              <a:spcBef>
+                <a:spcPts val="400"/>
+              </a:spcBef>
+              <a:defRPr sz="1050">
+                <a:solidFill>
+                  <a:srgbClr val="334155"/>
+                </a:solidFill>
+              </a:defRPr>
+            </a:pPr>
+            <a:r>
+              <a:t>Linear state alias mapping</a:t>
+            </a:r>
+          </a:p>
+          <a:p>
+            <a:pPr>
+              <a:spcBef>
+                <a:spcPts val="400"/>
+              </a:spcBef>
+              <a:defRPr sz="1050">
+                <a:solidFill>
+                  <a:srgbClr val="334155"/>
+                </a:solidFill>
+              </a:defRPr>
+            </a:pPr>
+            <a:r>
+              <a:t>retry/backoff scheduler</a:t>
+            </a:r>
+          </a:p>
+          <a:p>
+            <a:pPr>
+              <a:spcBef>
+                <a:spcPts val="400"/>
+              </a:spcBef>
+              <a:defRPr sz="1050">
+                <a:solidFill>
+                  <a:srgbClr val="334155"/>
+                </a:solidFill>
+              </a:defRPr>
+            </a:pPr>
+            <a:r>
+              <a:t>ClaudeRunner + WorkspaceManager</a:t>
+            </a:r>
+          </a:p>
+        </p:txBody>
+      </p:sp>
+      <p:sp>
+        <p:nvSpPr>
+          <p:cNvPr id="7" name="Rounded Rectangle 6"/>
+          <p:cNvSpPr/>
+          <p:nvPr/>
+        </p:nvSpPr>
+        <p:spPr>
+          <a:xfrm>
+            <a:off x="9144000" y="1417320"/>
+            <a:ext cx="2514600" cy="4297680"/>
+          </a:xfrm>
+          <a:prstGeom prst="roundRect">
+            <a:avLst/>
+          </a:prstGeom>
+          <a:solidFill>
+            <a:srgbClr val="F5F3FF"/>
+          </a:solidFill>
+          <a:ln w="15240">
+            <a:solidFill>
+              <a:srgbClr val="8B5CF6"/>
+            </a:solidFill>
+          </a:ln>
+        </p:spPr>
+        <p:style>
+          <a:lnRef idx="1">
+            <a:schemeClr val="accent1"/>
+          </a:lnRef>
+          <a:fillRef idx="3">
+            <a:schemeClr val="accent1"/>
+          </a:fillRef>
+          <a:effectRef idx="2">
+            <a:schemeClr val="accent1"/>
+          </a:effectRef>
+          <a:fontRef idx="minor">
+            <a:schemeClr val="lt1"/>
+          </a:fontRef>
+        </p:style>
+        <p:txBody>
+          <a:bodyPr rtlCol="0" anchor="t" lIns="109728" rIns="109728" tIns="73152" bIns="73152"/>
+          <a:lstStyle/>
+          <a:p>
+            <a:pPr algn="ctr">
+              <a:defRPr sz="1300" b="1">
+                <a:solidFill>
+                  <a:srgbClr val="0F172A"/>
+                </a:solidFill>
+              </a:defRPr>
+            </a:pPr>
+            <a:r>
+              <a:t>Delivery repo</a:t>
+            </a:r>
+          </a:p>
+          <a:p>
+            <a:pPr>
+              <a:spcBef>
+                <a:spcPts val="400"/>
+              </a:spcBef>
+              <a:defRPr sz="1050">
+                <a:solidFill>
+                  <a:srgbClr val="334155"/>
+                </a:solidFill>
+              </a:defRPr>
+            </a:pPr>
+            <a:r>
+              <a:t>agent/&lt;issue-key&gt; branch</a:t>
+            </a:r>
+          </a:p>
+          <a:p>
+            <a:pPr>
+              <a:spcBef>
+                <a:spcPts val="400"/>
+              </a:spcBef>
+              <a:defRPr sz="1050">
+                <a:solidFill>
+                  <a:srgbClr val="334155"/>
+                </a:solidFill>
+              </a:defRPr>
+            </a:pPr>
+            <a:r>
+              <a:t>GitHub pull request</a:t>
+            </a:r>
+          </a:p>
+          <a:p>
+            <a:pPr>
+              <a:spcBef>
+                <a:spcPts val="400"/>
+              </a:spcBef>
+              <a:defRPr sz="1050">
+                <a:solidFill>
+                  <a:srgbClr val="334155"/>
+                </a:solidFill>
+              </a:defRPr>
+            </a:pPr>
+            <a:r>
+              <a:t>result.json proof contract</a:t>
+            </a:r>
+          </a:p>
+          <a:p>
+            <a:pPr>
+              <a:spcBef>
+                <a:spcPts val="400"/>
+              </a:spcBef>
+              <a:defRPr sz="1050">
+                <a:solidFill>
+                  <a:srgbClr val="334155"/>
+                </a:solidFill>
+              </a:defRPr>
+            </a:pPr>
+            <a:r>
+              <a:t>review reports</a:t>
+            </a:r>
+          </a:p>
+          <a:p>
+            <a:pPr>
+              <a:spcBef>
+                <a:spcPts val="400"/>
+              </a:spcBef>
+              <a:defRPr sz="1050">
+                <a:solidFill>
+                  <a:srgbClr val="334155"/>
+                </a:solidFill>
+              </a:defRPr>
+            </a:pPr>
+            <a:r>
+              <a:t>human merge decision</a:t>
+            </a:r>
+          </a:p>
+        </p:txBody>
+      </p:sp>
+      <p:cxnSp>
+        <p:nvCxnSpPr>
+          <p:cNvPr id="8" name="Connector 7"/>
+          <p:cNvCxnSpPr/>
+          <p:nvPr/>
+        </p:nvCxnSpPr>
+        <p:spPr>
+          <a:xfrm>
+            <a:off x="2880360" y="3584448"/>
+            <a:ext cx="411480" cy="0"/>
+          </a:xfrm>
+          <a:prstGeom prst="line">
+            <a:avLst/>
+          </a:prstGeom>
+          <a:ln w="19050">
+            <a:solidFill>
+              <a:srgbClr val="475569"/>
+            </a:solidFill>
+          </a:ln>
+        </p:spPr>
+        <p:style>
+          <a:lnRef idx="2">
+            <a:schemeClr val="accent1"/>
+          </a:lnRef>
+          <a:fillRef idx="0">
+            <a:schemeClr val="accent1"/>
+          </a:fillRef>
+          <a:effectRef idx="1">
+            <a:schemeClr val="accent1"/>
+          </a:effectRef>
+          <a:fontRef idx="minor">
+            <a:schemeClr val="tx1"/>
+          </a:fontRef>
+        </p:style>
+      </p:cxnSp>
+      <p:cxnSp>
+        <p:nvCxnSpPr>
+          <p:cNvPr id="9" name="Connector 8"/>
+          <p:cNvCxnSpPr/>
+          <p:nvPr/>
+        </p:nvCxnSpPr>
+        <p:spPr>
+          <a:xfrm>
+            <a:off x="5760720" y="3584448"/>
+            <a:ext cx="411480" cy="0"/>
+          </a:xfrm>
+          <a:prstGeom prst="line">
+            <a:avLst/>
+          </a:prstGeom>
+          <a:ln w="19050">
+            <a:solidFill>
+              <a:srgbClr val="475569"/>
+            </a:solidFill>
+          </a:ln>
+        </p:spPr>
+        <p:style>
+          <a:lnRef idx="2">
+            <a:schemeClr val="accent1"/>
+          </a:lnRef>
+          <a:fillRef idx="0">
+            <a:schemeClr val="accent1"/>
+          </a:fillRef>
+          <a:effectRef idx="1">
+            <a:schemeClr val="accent1"/>
+          </a:effectRef>
+          <a:fontRef idx="minor">
+            <a:schemeClr val="tx1"/>
+          </a:fontRef>
+        </p:style>
+      </p:cxnSp>
+      <p:cxnSp>
+        <p:nvCxnSpPr>
+          <p:cNvPr id="10" name="Connector 9"/>
+          <p:cNvCxnSpPr/>
+          <p:nvPr/>
+        </p:nvCxnSpPr>
+        <p:spPr>
+          <a:xfrm>
+            <a:off x="8641080" y="3584448"/>
+            <a:ext cx="411479" cy="0"/>
+          </a:xfrm>
+          <a:prstGeom prst="line">
+            <a:avLst/>
+          </a:prstGeom>
+          <a:ln w="19050">
+            <a:solidFill>
+              <a:srgbClr val="475569"/>
+            </a:solidFill>
+          </a:ln>
+        </p:spPr>
+        <p:style>
+          <a:lnRef idx="2">
+            <a:schemeClr val="accent1"/>
+          </a:lnRef>
+          <a:fillRef idx="0">
+            <a:schemeClr val="accent1"/>
+          </a:fillRef>
+          <a:effectRef idx="1">
+            <a:schemeClr val="accent1"/>
+          </a:effectRef>
+          <a:fontRef idx="minor">
+            <a:schemeClr val="tx1"/>
+          </a:fontRef>
+        </p:style>
+      </p:cxnSp>
+      <p:sp>
+        <p:nvSpPr>
+          <p:cNvPr id="11" name="Rounded Rectangle 10"/>
+          <p:cNvSpPr/>
+          <p:nvPr/>
+        </p:nvSpPr>
+        <p:spPr>
+          <a:xfrm>
+            <a:off x="960120" y="5897880"/>
+            <a:ext cx="10287000" cy="320040"/>
+          </a:xfrm>
+          <a:prstGeom prst="roundRect">
+            <a:avLst/>
+          </a:prstGeom>
+          <a:solidFill>
+            <a:srgbClr val="FFFFFF"/>
+          </a:solidFill>
+          <a:ln w="15240">
+            <a:solidFill>
+              <a:srgbClr val="94A3B8"/>
+            </a:solidFill>
+          </a:ln>
+        </p:spPr>
+        <p:style>
+          <a:lnRef idx="1">
+            <a:schemeClr val="accent1"/>
+          </a:lnRef>
+          <a:fillRef idx="3">
+            <a:schemeClr val="accent1"/>
+          </a:fillRef>
+          <a:effectRef idx="2">
+            <a:schemeClr val="accent1"/>
+          </a:effectRef>
+          <a:fontRef idx="minor">
+            <a:schemeClr val="lt1"/>
+          </a:fontRef>
+        </p:style>
+        <p:txBody>
+          <a:bodyPr rtlCol="0" anchor="t" lIns="109728" rIns="109728" tIns="73152" bIns="73152"/>
+          <a:lstStyle/>
+          <a:p>
+            <a:pPr algn="ctr">
+              <a:defRPr sz="1300" b="1">
+                <a:solidFill>
+                  <a:srgbClr val="0F172A"/>
+                </a:solidFill>
+              </a:defRPr>
+            </a:pPr>
+            <a:r>
+              <a:t>Key rule: symphony_clone/ is versioned with the harness repo, but /scaffold does not copy it into applications.</a:t>
+            </a:r>
+          </a:p>
+        </p:txBody>
+      </p:sp>
+      <p:sp>
+        <p:nvSpPr>
+          <p:cNvPr id="12" name="TextBox 11"/>
+          <p:cNvSpPr txBox="1"/>
+          <p:nvPr/>
+        </p:nvSpPr>
+        <p:spPr>
+          <a:xfrm>
+            <a:off x="411480" y="6446520"/>
+            <a:ext cx="6766560" cy="228600"/>
+          </a:xfrm>
+          <a:prstGeom prst="rect">
+            <a:avLst/>
+          </a:prstGeom>
+          <a:noFill/>
+        </p:spPr>
+        <p:txBody>
+          <a:bodyPr wrap="none">
+            <a:spAutoFit/>
+          </a:bodyPr>
+          <a:lstStyle/>
+          <a:p>
+            <a:pPr>
+              <a:defRPr sz="850">
+                <a:solidFill>
+                  <a:srgbClr val="566070"/>
+                </a:solidFill>
+              </a:defRPr>
+            </a:pPr>
+            <a:r>
+              <a:t>Claude Harness Engine v1.1.4   ·   Agent Factory + Tracker Orchestration</a:t>
+            </a:r>
+          </a:p>
+        </p:txBody>
+      </p:sp>
+      <p:sp>
+        <p:nvSpPr>
+          <p:cNvPr id="13" name="TextBox 12"/>
+          <p:cNvSpPr txBox="1"/>
+          <p:nvPr/>
+        </p:nvSpPr>
+        <p:spPr>
+          <a:xfrm>
+            <a:off x="10972800" y="6446520"/>
+            <a:ext cx="731520" cy="228600"/>
+          </a:xfrm>
+          <a:prstGeom prst="rect">
+            <a:avLst/>
+          </a:prstGeom>
+          <a:noFill/>
+        </p:spPr>
+        <p:txBody>
+          <a:bodyPr wrap="none">
+            <a:spAutoFit/>
+          </a:bodyPr>
+          <a:lstStyle/>
+          <a:p>
+            <a:pPr algn="r">
+              <a:defRPr sz="850">
+                <a:solidFill>
+                  <a:srgbClr val="566070"/>
+                </a:solidFill>
+              </a:defRPr>
+            </a:pPr>
+            <a:r>
+              <a:t>33 / 34</a:t>
+            </a:r>
+          </a:p>
+        </p:txBody>
+      </p:sp>
+    </p:spTree>
+  </p:cSld>
+  <p:clrMapOvr>
+    <a:masterClrMapping/>
+  </p:clrMapOvr>
+</p:sld>
+</file>
+
+<file path=ppt/slides/slide34.xml><?xml version="1.0" encoding="utf-8"?>
+<p:sld xmlns:a="http://schemas.openxmlformats.org/drawingml/2006/main" xmlns:p="http://schemas.openxmlformats.org/presentationml/2006/main" xmlns:r="http://schemas.openxmlformats.org/officeDocument/2006/relationships">
+  <p:cSld>
+    <p:spTree>
+      <p:nvGrpSpPr>
+        <p:cNvPr id="1" name=""/>
+        <p:cNvGrpSpPr/>
+        <p:nvPr/>
+      </p:nvGrpSpPr>
+      <p:grpSpPr/>
+      <p:sp>
+        <p:nvSpPr>
+          <p:cNvPr id="2" name="TextBox 1"/>
+          <p:cNvSpPr txBox="1"/>
+          <p:nvPr/>
+        </p:nvSpPr>
+        <p:spPr>
+          <a:xfrm>
+            <a:off x="502920" y="320040"/>
+            <a:ext cx="11155680" cy="502920"/>
+          </a:xfrm>
+          <a:prstGeom prst="rect">
+            <a:avLst/>
+          </a:prstGeom>
+          <a:noFill/>
+        </p:spPr>
+        <p:txBody>
+          <a:bodyPr wrap="none">
+            <a:spAutoFit/>
+          </a:bodyPr>
+          <a:lstStyle/>
+          <a:p>
+            <a:pPr>
+              <a:defRPr sz="2700" b="1">
+                <a:solidFill>
+                  <a:srgbClr val="111827"/>
+                </a:solidFill>
+              </a:defRPr>
+            </a:pPr>
+            <a:r>
+              <a:t>Agent Factory Hardening Controls</a:t>
+            </a:r>
+          </a:p>
+        </p:txBody>
+      </p:sp>
+      <p:sp>
+        <p:nvSpPr>
+          <p:cNvPr id="3" name="TextBox 2"/>
+          <p:cNvSpPr txBox="1"/>
+          <p:nvPr/>
+        </p:nvSpPr>
+        <p:spPr>
+          <a:xfrm>
+            <a:off x="530352" y="841248"/>
+            <a:ext cx="10789920" cy="301752"/>
+          </a:xfrm>
+          <a:prstGeom prst="rect">
+            <a:avLst/>
+          </a:prstGeom>
+          <a:noFill/>
+        </p:spPr>
+        <p:txBody>
+          <a:bodyPr wrap="none">
+            <a:spAutoFit/>
+          </a:bodyPr>
+          <a:lstStyle/>
+          <a:p>
+            <a:pPr>
+              <a:defRPr sz="1250">
+                <a:solidFill>
+                  <a:srgbClr val="4B5563"/>
+                </a:solidFill>
+              </a:defRPr>
+            </a:pPr>
+            <a:r>
+              <a:t>The orchestrator is deliberately boring infrastructure: deterministic state, visible logs, safe retries, explicit review gates.</a:t>
+            </a:r>
+          </a:p>
+        </p:txBody>
+      </p:sp>
+      <p:sp>
+        <p:nvSpPr>
+          <p:cNvPr id="4" name="Rounded Rectangle 3"/>
+          <p:cNvSpPr/>
+          <p:nvPr/>
+        </p:nvSpPr>
+        <p:spPr>
+          <a:xfrm>
+            <a:off x="594360" y="1325880"/>
+            <a:ext cx="3429000" cy="4160520"/>
+          </a:xfrm>
+          <a:prstGeom prst="roundRect">
+            <a:avLst/>
+          </a:prstGeom>
+          <a:solidFill>
+            <a:srgbClr val="FFFBEB"/>
+          </a:solidFill>
+          <a:ln w="15240">
+            <a:solidFill>
+              <a:srgbClr val="F59E0B"/>
+            </a:solidFill>
+          </a:ln>
+        </p:spPr>
+        <p:style>
+          <a:lnRef idx="1">
+            <a:schemeClr val="accent1"/>
+          </a:lnRef>
+          <a:fillRef idx="3">
+            <a:schemeClr val="accent1"/>
+          </a:fillRef>
+          <a:effectRef idx="2">
+            <a:schemeClr val="accent1"/>
+          </a:effectRef>
+          <a:fontRef idx="minor">
+            <a:schemeClr val="lt1"/>
+          </a:fontRef>
+        </p:style>
+        <p:txBody>
+          <a:bodyPr rtlCol="0" anchor="t" lIns="109728" rIns="109728" tIns="73152" bIns="73152"/>
+          <a:lstStyle/>
+          <a:p>
+            <a:pPr algn="ctr">
+              <a:defRPr sz="1300" b="1">
+                <a:solidFill>
+                  <a:srgbClr val="0F172A"/>
+                </a:solidFill>
+              </a:defRPr>
+            </a:pPr>
+            <a:r>
+              <a:t>Retry policy</a:t>
+            </a:r>
+          </a:p>
+          <a:p>
+            <a:pPr>
+              <a:spcBef>
+                <a:spcPts val="400"/>
+              </a:spcBef>
+              <a:defRPr sz="1050">
+                <a:solidFill>
+                  <a:srgbClr val="334155"/>
+                </a:solidFill>
+              </a:defRPr>
+            </a:pPr>
+            <a:r>
+              <a:t>MAX_RETRY_ATTEMPTS controls final block</a:t>
+            </a:r>
+          </a:p>
+          <a:p>
+            <a:pPr>
+              <a:spcBef>
+                <a:spcPts val="400"/>
+              </a:spcBef>
+              <a:defRPr sz="1050">
+                <a:solidFill>
+                  <a:srgbClr val="334155"/>
+                </a:solidFill>
+              </a:defRPr>
+            </a:pPr>
+            <a:r>
+              <a:t>Exponential backoff: base * 2^(attempt-1)</a:t>
+            </a:r>
+          </a:p>
+          <a:p>
+            <a:pPr>
+              <a:spcBef>
+                <a:spcPts val="400"/>
+              </a:spcBef>
+              <a:defRPr sz="1050">
+                <a:solidFill>
+                  <a:srgbClr val="334155"/>
+                </a:solidFill>
+              </a:defRPr>
+            </a:pPr>
+            <a:r>
+              <a:t>Failures stay retry_wait until due</a:t>
+            </a:r>
+          </a:p>
+          <a:p>
+            <a:pPr>
+              <a:spcBef>
+                <a:spcPts val="400"/>
+              </a:spcBef>
+              <a:defRPr sz="1050">
+                <a:solidFill>
+                  <a:srgbClr val="334155"/>
+                </a:solidFill>
+              </a:defRPr>
+            </a:pPr>
+            <a:r>
+              <a:t>Tracker is moved to blocked only after exhaustion</a:t>
+            </a:r>
+          </a:p>
+        </p:txBody>
+      </p:sp>
+      <p:sp>
+        <p:nvSpPr>
+          <p:cNvPr id="5" name="Rounded Rectangle 4"/>
+          <p:cNvSpPr/>
+          <p:nvPr/>
+        </p:nvSpPr>
+        <p:spPr>
+          <a:xfrm>
+            <a:off x="4389120" y="1325880"/>
+            <a:ext cx="3429000" cy="4160520"/>
+          </a:xfrm>
+          <a:prstGeom prst="roundRect">
+            <a:avLst/>
+          </a:prstGeom>
+          <a:solidFill>
+            <a:srgbClr val="F0FDF4"/>
+          </a:solidFill>
+          <a:ln w="15240">
+            <a:solidFill>
+              <a:srgbClr val="22C55E"/>
+            </a:solidFill>
+          </a:ln>
+        </p:spPr>
+        <p:style>
+          <a:lnRef idx="1">
+            <a:schemeClr val="accent1"/>
+          </a:lnRef>
+          <a:fillRef idx="3">
+            <a:schemeClr val="accent1"/>
+          </a:fillRef>
+          <a:effectRef idx="2">
+            <a:schemeClr val="accent1"/>
+          </a:effectRef>
+          <a:fontRef idx="minor">
+            <a:schemeClr val="lt1"/>
+          </a:fontRef>
+        </p:style>
+        <p:txBody>
+          <a:bodyPr rtlCol="0" anchor="t" lIns="109728" rIns="109728" tIns="73152" bIns="73152"/>
+          <a:lstStyle/>
+          <a:p>
+            <a:pPr algn="ctr">
+              <a:defRPr sz="1300" b="1">
+                <a:solidFill>
+                  <a:srgbClr val="0F172A"/>
+                </a:solidFill>
+              </a:defRPr>
+            </a:pPr>
+            <a:r>
+              <a:t>Workspace state mapping</a:t>
+            </a:r>
+          </a:p>
+          <a:p>
+            <a:pPr>
+              <a:spcBef>
+                <a:spcPts val="400"/>
+              </a:spcBef>
+              <a:defRPr sz="1050">
+                <a:solidFill>
+                  <a:srgbClr val="334155"/>
+                </a:solidFill>
+              </a:defRPr>
+            </a:pPr>
+            <a:r>
+              <a:t>READY_STATE + READY_LABEL gate dispatch</a:t>
+            </a:r>
+          </a:p>
+          <a:p>
+            <a:pPr>
+              <a:spcBef>
+                <a:spcPts val="400"/>
+              </a:spcBef>
+              <a:defRPr sz="1050">
+                <a:solidFill>
+                  <a:srgbClr val="334155"/>
+                </a:solidFill>
+              </a:defRPr>
+            </a:pPr>
+            <a:r>
+              <a:t>REVIEW_STATE_CANDIDATES handles Linear variants</a:t>
+            </a:r>
+          </a:p>
+          <a:p>
+            <a:pPr>
+              <a:spcBef>
+                <a:spcPts val="400"/>
+              </a:spcBef>
+              <a:defRPr sz="1050">
+                <a:solidFill>
+                  <a:srgbClr val="334155"/>
+                </a:solidFill>
+              </a:defRPr>
+            </a:pPr>
+            <a:r>
+              <a:t>BLOCKED_STATE_CANDIDATES avoids brittle workflows</a:t>
+            </a:r>
+          </a:p>
+          <a:p>
+            <a:pPr>
+              <a:spcBef>
+                <a:spcPts val="400"/>
+              </a:spcBef>
+              <a:defRPr sz="1050">
+                <a:solidFill>
+                  <a:srgbClr val="334155"/>
+                </a:solidFill>
+              </a:defRPr>
+            </a:pPr>
+            <a:r>
+              <a:t>Terminal blocker states prevent premature clusters</a:t>
+            </a:r>
+          </a:p>
+        </p:txBody>
+      </p:sp>
+      <p:sp>
+        <p:nvSpPr>
+          <p:cNvPr id="6" name="Rounded Rectangle 5"/>
+          <p:cNvSpPr/>
+          <p:nvPr/>
+        </p:nvSpPr>
+        <p:spPr>
+          <a:xfrm>
+            <a:off x="8183879" y="1325880"/>
+            <a:ext cx="3429000" cy="4160520"/>
+          </a:xfrm>
+          <a:prstGeom prst="roundRect">
+            <a:avLst/>
+          </a:prstGeom>
+          <a:solidFill>
+            <a:srgbClr val="EFF6FF"/>
+          </a:solidFill>
+          <a:ln w="15240">
+            <a:solidFill>
+              <a:srgbClr val="3B82F6"/>
+            </a:solidFill>
+          </a:ln>
+        </p:spPr>
+        <p:style>
+          <a:lnRef idx="1">
+            <a:schemeClr val="accent1"/>
+          </a:lnRef>
+          <a:fillRef idx="3">
+            <a:schemeClr val="accent1"/>
+          </a:fillRef>
+          <a:effectRef idx="2">
+            <a:schemeClr val="accent1"/>
+          </a:effectRef>
+          <a:fontRef idx="minor">
+            <a:schemeClr val="lt1"/>
+          </a:fontRef>
+        </p:style>
+        <p:txBody>
+          <a:bodyPr rtlCol="0" anchor="t" lIns="109728" rIns="109728" tIns="73152" bIns="73152"/>
+          <a:lstStyle/>
+          <a:p>
+            <a:pPr algn="ctr">
+              <a:defRPr sz="1300" b="1">
+                <a:solidFill>
+                  <a:srgbClr val="0F172A"/>
+                </a:solidFill>
+              </a:defRPr>
+            </a:pPr>
+            <a:r>
+              <a:t>Visibility + security</a:t>
+            </a:r>
+          </a:p>
+          <a:p>
+            <a:pPr>
+              <a:spcBef>
+                <a:spcPts val="400"/>
+              </a:spcBef>
+              <a:defRPr sz="1050">
+                <a:solidFill>
+                  <a:srgbClr val="334155"/>
+                </a:solidFill>
+              </a:defRPr>
+            </a:pPr>
+            <a:r>
+              <a:t>STATE_DIR/state.json records every run</a:t>
+            </a:r>
+          </a:p>
+          <a:p>
+            <a:pPr>
+              <a:spcBef>
+                <a:spcPts val="400"/>
+              </a:spcBef>
+              <a:defRPr sz="1050">
+                <a:solidFill>
+                  <a:srgbClr val="334155"/>
+                </a:solidFill>
+              </a:defRPr>
+            </a:pPr>
+            <a:r>
+              <a:t>LOG_ROOT/orchestrator.jsonl gives event history</a:t>
+            </a:r>
+          </a:p>
+          <a:p>
+            <a:pPr>
+              <a:spcBef>
+                <a:spcPts val="400"/>
+              </a:spcBef>
+              <a:defRPr sz="1050">
+                <a:solidFill>
+                  <a:srgbClr val="334155"/>
+                </a:solidFill>
+              </a:defRPr>
+            </a:pPr>
+            <a:r>
+              <a:t>STATUS_PORT exposes /, /health, /state</a:t>
+            </a:r>
+          </a:p>
+          <a:p>
+            <a:pPr>
+              <a:spcBef>
+                <a:spcPts val="400"/>
+              </a:spcBef>
+              <a:defRPr sz="1050">
+                <a:solidFill>
+                  <a:srgbClr val="334155"/>
+                </a:solidFill>
+              </a:defRPr>
+            </a:pPr>
+            <a:r>
+              <a:t>.env is runtime-only; secrets are never scaffolded</a:t>
+            </a:r>
+          </a:p>
+        </p:txBody>
+      </p:sp>
+      <p:sp>
+        <p:nvSpPr>
+          <p:cNvPr id="7" name="Rounded Rectangle 6"/>
+          <p:cNvSpPr/>
+          <p:nvPr/>
+        </p:nvSpPr>
+        <p:spPr>
+          <a:xfrm>
+            <a:off x="914400" y="5806440"/>
+            <a:ext cx="10332720" cy="411480"/>
+          </a:xfrm>
+          <a:prstGeom prst="roundRect">
+            <a:avLst/>
+          </a:prstGeom>
+          <a:solidFill>
+            <a:srgbClr val="F8FAFC"/>
+          </a:solidFill>
+          <a:ln w="15240">
+            <a:solidFill>
+              <a:srgbClr val="94A3B8"/>
+            </a:solidFill>
+          </a:ln>
+        </p:spPr>
+        <p:style>
+          <a:lnRef idx="1">
+            <a:schemeClr val="accent1"/>
+          </a:lnRef>
+          <a:fillRef idx="3">
+            <a:schemeClr val="accent1"/>
+          </a:fillRef>
+          <a:effectRef idx="2">
+            <a:schemeClr val="accent1"/>
+          </a:effectRef>
+          <a:fontRef idx="minor">
+            <a:schemeClr val="lt1"/>
+          </a:fontRef>
+        </p:style>
+        <p:txBody>
+          <a:bodyPr rtlCol="0" anchor="t" lIns="109728" rIns="109728" tIns="73152" bIns="73152"/>
+          <a:lstStyle/>
+          <a:p>
+            <a:pPr algn="ctr">
+              <a:defRPr sz="1300" b="1">
+                <a:solidFill>
+                  <a:srgbClr val="0F172A"/>
+                </a:solidFill>
+              </a:defRPr>
+            </a:pPr>
+            <a:r>
+              <a:t>Result: a repeatable SDLC agent factory: tracker chooses the cluster, symphony_clone creates the workspace, Claude Harness forms the team, GitHub receives the reviewable change.</a:t>
+            </a:r>
+          </a:p>
+        </p:txBody>
+      </p:sp>
+      <p:sp>
+        <p:nvSpPr>
+          <p:cNvPr id="8" name="TextBox 7"/>
+          <p:cNvSpPr txBox="1"/>
+          <p:nvPr/>
+        </p:nvSpPr>
+        <p:spPr>
+          <a:xfrm>
+            <a:off x="411480" y="6446520"/>
+            <a:ext cx="6766560" cy="228600"/>
+          </a:xfrm>
+          <a:prstGeom prst="rect">
+            <a:avLst/>
+          </a:prstGeom>
+          <a:noFill/>
+        </p:spPr>
+        <p:txBody>
+          <a:bodyPr wrap="none">
+            <a:spAutoFit/>
+          </a:bodyPr>
+          <a:lstStyle/>
+          <a:p>
+            <a:pPr>
+              <a:defRPr sz="850">
+                <a:solidFill>
+                  <a:srgbClr val="566070"/>
+                </a:solidFill>
+              </a:defRPr>
+            </a:pPr>
+            <a:r>
+              <a:t>Claude Harness Engine v1.1.4   ·   Agent Factory + Tracker Orchestration</a:t>
+            </a:r>
+          </a:p>
+        </p:txBody>
+      </p:sp>
+      <p:sp>
+        <p:nvSpPr>
+          <p:cNvPr id="9" name="TextBox 8"/>
+          <p:cNvSpPr txBox="1"/>
+          <p:nvPr/>
+        </p:nvSpPr>
+        <p:spPr>
+          <a:xfrm>
+            <a:off x="10972800" y="6446520"/>
+            <a:ext cx="731520" cy="228600"/>
+          </a:xfrm>
+          <a:prstGeom prst="rect">
+            <a:avLst/>
+          </a:prstGeom>
+          <a:noFill/>
+        </p:spPr>
+        <p:txBody>
+          <a:bodyPr wrap="none">
+            <a:spAutoFit/>
+          </a:bodyPr>
+          <a:lstStyle/>
+          <a:p>
+            <a:pPr algn="r">
+              <a:defRPr sz="850">
+                <a:solidFill>
+                  <a:srgbClr val="566070"/>
+                </a:solidFill>
+              </a:defRPr>
+            </a:pPr>
+            <a:r>
+              <a:t>34 / 34</a:t>
             </a:r>
           </a:p>
         </p:txBody>
@@ -32871,7 +35452,7 @@
                 </a:solidFill>
                 <a:latin typeface="Calibri"/>
               </a:rPr>
-              <a:t>Claude Harness Engine v1.1.1   ·   Autonomous SDLC for Agentic Software</a:t>
+              <a:t>Claude Harness Engine v1.1.4   ·   Autonomous SDLC for Agentic Software</a:t>
             </a:r>
           </a:p>
         </p:txBody>
@@ -32906,7 +35487,7 @@
                 </a:solidFill>
                 <a:latin typeface="Calibri"/>
               </a:rPr>
-              <a:t>4 / 30</a:t>
+              <a:t>4 / 34</a:t>
             </a:r>
           </a:p>
         </p:txBody>
@@ -33251,7 +35832,7 @@
                 </a:solidFill>
                 <a:latin typeface="Consolas"/>
               </a:rPr>
-              <a:t>├─ skills/  (21)  </a:t>
+              <a:t>├─ skills/  (23)  </a:t>
             </a:r>
             <a:r>
               <a:rPr sz="1000">
@@ -33301,7 +35882,7 @@
                 </a:solidFill>
                 <a:latin typeface="Consolas"/>
               </a:rPr>
-              <a:t>├─ hooks/   (14)  </a:t>
+              <a:t>├─ hooks/   (15)  </a:t>
             </a:r>
             <a:r>
               <a:rPr sz="1000">
@@ -33708,7 +36289,7 @@
                 </a:solidFill>
                 <a:latin typeface="Calibri"/>
               </a:rPr>
-              <a:t>Claude Harness Engine v1.1.1   ·   Autonomous SDLC for Agentic Software</a:t>
+              <a:t>Claude Harness Engine v1.1.4   ·   Autonomous SDLC for Agentic Software</a:t>
             </a:r>
           </a:p>
         </p:txBody>
@@ -33743,7 +36324,7 @@
                 </a:solidFill>
                 <a:latin typeface="Calibri"/>
               </a:rPr>
-              <a:t>5 / 30</a:t>
+              <a:t>5 / 34</a:t>
             </a:r>
           </a:p>
         </p:txBody>
@@ -34933,7 +37514,7 @@
                 </a:solidFill>
                 <a:latin typeface="Calibri"/>
               </a:rPr>
-              <a:t>Claude Harness Engine v1.1.1   ·   Autonomous SDLC for Agentic Software</a:t>
+              <a:t>Claude Harness Engine v1.1.4   ·   Autonomous SDLC for Agentic Software</a:t>
             </a:r>
           </a:p>
         </p:txBody>
@@ -34968,7 +37549,7 @@
                 </a:solidFill>
                 <a:latin typeface="Calibri"/>
               </a:rPr>
-              <a:t>6 / 30</a:t>
+              <a:t>6 / 34</a:t>
             </a:r>
           </a:p>
         </p:txBody>
@@ -35728,7 +38309,7 @@
                 </a:solidFill>
                 <a:latin typeface="Calibri"/>
               </a:rPr>
-              <a:t>Claude Harness Engine v1.1.1   ·   Autonomous SDLC for Agentic Software</a:t>
+              <a:t>Claude Harness Engine v1.1.4   ·   Autonomous SDLC for Agentic Software</a:t>
             </a:r>
           </a:p>
         </p:txBody>
@@ -35763,7 +38344,7 @@
                 </a:solidFill>
                 <a:latin typeface="Calibri"/>
               </a:rPr>
-              <a:t>7 / 30</a:t>
+              <a:t>7 / 34</a:t>
             </a:r>
           </a:p>
         </p:txBody>
@@ -38720,7 +41301,7 @@
                 </a:solidFill>
                 <a:latin typeface="Calibri"/>
               </a:rPr>
-              <a:t>Claude Harness Engine v1.1.1   ·   Autonomous SDLC for Agentic Software</a:t>
+              <a:t>Claude Harness Engine v1.1.4   ·   Autonomous SDLC for Agentic Software</a:t>
             </a:r>
           </a:p>
         </p:txBody>
@@ -38755,7 +41336,7 @@
                 </a:solidFill>
                 <a:latin typeface="Calibri"/>
               </a:rPr>
-              <a:t>8 / 30</a:t>
+              <a:t>8 / 34</a:t>
             </a:r>
           </a:p>
         </p:txBody>
@@ -38895,7 +41476,7 @@
                 </a:solidFill>
                 <a:latin typeface="Calibri"/>
               </a:rPr>
-              <a:t>The 21 Skills, Grouped by Purpose</a:t>
+              <a:t>The 23 Skills, Grouped by Purpose</a:t>
             </a:r>
           </a:p>
         </p:txBody>
@@ -39752,7 +42333,7 @@
                 </a:solidFill>
                 <a:latin typeface="Calibri"/>
               </a:rPr>
-              <a:t>Claude Harness Engine v1.1.1   ·   Autonomous SDLC for Agentic Software</a:t>
+              <a:t>Claude Harness Engine v1.1.4   ·   Autonomous SDLC for Agentic Software</a:t>
             </a:r>
           </a:p>
         </p:txBody>
@@ -39787,7 +42368,50 @@
                 </a:solidFill>
                 <a:latin typeface="Calibri"/>
               </a:rPr>
-              <a:t>9 / 30</a:t>
+              <a:t>9 / 34</a:t>
+            </a:r>
+          </a:p>
+        </p:txBody>
+      </p:sp>
+      <p:sp>
+        <p:nvSpPr>
+          <p:cNvPr id="21" name="TextBox 20"/>
+          <p:cNvSpPr txBox="1"/>
+          <p:nvPr/>
+        </p:nvSpPr>
+        <p:spPr>
+          <a:xfrm>
+            <a:off x="8732520" y="5074920"/>
+            <a:ext cx="2743200" cy="640080"/>
+          </a:xfrm>
+          <a:prstGeom prst="rect">
+            <a:avLst/>
+          </a:prstGeom>
+          <a:noFill/>
+        </p:spPr>
+        <p:txBody>
+          <a:bodyPr wrap="none">
+            <a:spAutoFit/>
+          </a:bodyPr>
+          <a:lstStyle/>
+          <a:p>
+            <a:pPr>
+              <a:defRPr sz="1200" b="1">
+                <a:solidFill>
+                  <a:srgbClr val="1F3558"/>
+                </a:solidFill>
+              </a:defRPr>
+            </a:pPr>
+            <a:r>
+              <a:t>Tracker add-on</a:t>
+            </a:r>
+            <a:br/>
+            <a:r>
+              <a:t>▸ /tracker</a:t>
+            </a:r>
+            <a:br/>
+            <a:r>
+              <a:t>▸ /tracker-publish</a:t>
             </a:r>
           </a:p>
         </p:txBody>

</xml_diff>

<commit_message>
feat: add graph-grounded brownfield discovery
</commit_message>
<xml_diff>
--- a/Claude_Harness_Engine_Design.pptx
+++ b/Claude_Harness_Engine_Design.pptx
@@ -39,6 +39,8 @@
     <p:sldId id="287" r:id="rId38"/>
     <p:sldId id="288" r:id="rId39"/>
     <p:sldId id="289" r:id="rId40"/>
+    <p:sldId id="290" r:id="rId41"/>
+    <p:sldId id="291" r:id="rId42"/>
   </p:sldIdLst>
   <p:sldSz cx="9144000" cy="5143500" type="screen4x3"/>
   <p:notesSz cx="6858000" cy="9144000"/>
@@ -3406,7 +3408,7 @@
                 </a:solidFill>
                 <a:latin typeface="Calibri"/>
               </a:rPr>
-              <a:t>23 SKILLS</a:t>
+              <a:t>25 SKILLS</a:t>
             </a:r>
           </a:p>
         </p:txBody>
@@ -4984,7 +4986,7 @@
                 </a:solidFill>
                 <a:latin typeface="Calibri"/>
               </a:rPr>
-              <a:t>10 / 34</a:t>
+              <a:t>10 / 36</a:t>
             </a:r>
           </a:p>
         </p:txBody>
@@ -6671,7 +6673,7 @@
                 </a:solidFill>
                 <a:latin typeface="Calibri"/>
               </a:rPr>
-              <a:t>11 / 34</a:t>
+              <a:t>11 / 36</a:t>
             </a:r>
           </a:p>
         </p:txBody>
@@ -8813,7 +8815,7 @@
                 </a:solidFill>
                 <a:latin typeface="Calibri"/>
               </a:rPr>
-              <a:t>12 / 34</a:t>
+              <a:t>12 / 36</a:t>
             </a:r>
           </a:p>
         </p:txBody>
@@ -9879,7 +9881,7 @@
                 </a:solidFill>
                 <a:latin typeface="Calibri"/>
               </a:rPr>
-              <a:t>13 / 34</a:t>
+              <a:t>13 / 36</a:t>
             </a:r>
           </a:p>
         </p:txBody>
@@ -12264,7 +12266,7 @@
                 </a:solidFill>
                 <a:latin typeface="Calibri"/>
               </a:rPr>
-              <a:t>14 / 34</a:t>
+              <a:t>14 / 36</a:t>
             </a:r>
           </a:p>
         </p:txBody>
@@ -13119,7 +13121,7 @@
                 </a:solidFill>
                 <a:latin typeface="Calibri"/>
               </a:rPr>
-              <a:t>15 / 34</a:t>
+              <a:t>15 / 36</a:t>
             </a:r>
           </a:p>
         </p:txBody>
@@ -14755,7 +14757,7 @@
                 </a:solidFill>
                 <a:latin typeface="Calibri"/>
               </a:rPr>
-              <a:t>16 / 34</a:t>
+              <a:t>16 / 36</a:t>
             </a:r>
           </a:p>
         </p:txBody>
@@ -16610,7 +16612,7 @@
                 </a:solidFill>
                 <a:latin typeface="Calibri"/>
               </a:rPr>
-              <a:t>17 / 34</a:t>
+              <a:t>17 / 36</a:t>
             </a:r>
           </a:p>
         </p:txBody>
@@ -17375,7 +17377,7 @@
                 </a:solidFill>
                 <a:latin typeface="Calibri"/>
               </a:rPr>
-              <a:t>18 / 34</a:t>
+              <a:t>18 / 36</a:t>
             </a:r>
           </a:p>
         </p:txBody>
@@ -18055,7 +18057,7 @@
                 </a:solidFill>
                 <a:latin typeface="Calibri"/>
               </a:rPr>
-              <a:t>19 / 34</a:t>
+              <a:t>19 / 36</a:t>
             </a:r>
           </a:p>
         </p:txBody>
@@ -18230,7 +18232,7 @@
                 </a:solidFill>
                 <a:latin typeface="Calibri"/>
               </a:rPr>
-              <a:t>Updates since the original deck — codebase now spans scaffold, lanes, plugins, hooks, and tracker orchestration</a:t>
+              <a:t>Updates since the original deck — codebase now spans scaffold, graph-grounded brownfield, plugins, hooks, and tracker orchestration</a:t>
             </a:r>
           </a:p>
         </p:txBody>
@@ -19055,7 +19057,7 @@
                 </a:solidFill>
                 <a:latin typeface="Calibri"/>
               </a:rPr>
-              <a:t>2 / 34</a:t>
+              <a:t>2 / 36</a:t>
             </a:r>
           </a:p>
         </p:txBody>
@@ -19863,7 +19865,7 @@
                 </a:solidFill>
                 <a:latin typeface="Calibri"/>
               </a:rPr>
-              <a:t>20 / 34</a:t>
+              <a:t>20 / 36</a:t>
             </a:r>
           </a:p>
         </p:txBody>
@@ -21258,7 +21260,7 @@
                 </a:solidFill>
                 <a:latin typeface="Calibri"/>
               </a:rPr>
-              <a:t>21 / 34</a:t>
+              <a:t>21 / 36</a:t>
             </a:r>
           </a:p>
         </p:txBody>
@@ -22702,7 +22704,7 @@
                 </a:solidFill>
                 <a:latin typeface="Calibri"/>
               </a:rPr>
-              <a:t>22 / 34</a:t>
+              <a:t>22 / 36</a:t>
             </a:r>
           </a:p>
         </p:txBody>
@@ -23815,7 +23817,7 @@
                 </a:solidFill>
                 <a:latin typeface="Calibri"/>
               </a:rPr>
-              <a:t>23 / 34</a:t>
+              <a:t>23 / 36</a:t>
             </a:r>
           </a:p>
         </p:txBody>
@@ -24920,7 +24922,7 @@
                 </a:solidFill>
                 <a:latin typeface="Calibri"/>
               </a:rPr>
-              <a:t>24 / 34</a:t>
+              <a:t>24 / 36</a:t>
             </a:r>
           </a:p>
         </p:txBody>
@@ -26128,7 +26130,7 @@
                 </a:solidFill>
                 <a:latin typeface="Calibri"/>
               </a:rPr>
-              <a:t>25 / 34</a:t>
+              <a:t>25 / 36</a:t>
             </a:r>
           </a:p>
         </p:txBody>
@@ -26935,7 +26937,7 @@
                 </a:solidFill>
                 <a:latin typeface="Calibri"/>
               </a:rPr>
-              <a:t>26 / 34</a:t>
+              <a:t>26 / 36</a:t>
             </a:r>
           </a:p>
         </p:txBody>
@@ -28342,7 +28344,7 @@
                 </a:solidFill>
                 <a:latin typeface="Calibri"/>
               </a:rPr>
-              <a:t>27 / 34</a:t>
+              <a:t>27 / 36</a:t>
             </a:r>
           </a:p>
         </p:txBody>
@@ -29280,7 +29282,7 @@
                 </a:solidFill>
                 <a:latin typeface="Calibri"/>
               </a:rPr>
-              <a:t>28 / 34</a:t>
+              <a:t>28 / 36</a:t>
             </a:r>
           </a:p>
         </p:txBody>
@@ -29974,7 +29976,7 @@
                 </a:solidFill>
                 <a:latin typeface="Calibri"/>
               </a:rPr>
-              <a:t>29 / 34</a:t>
+              <a:t>29 / 36</a:t>
             </a:r>
           </a:p>
         </p:txBody>
@@ -30734,7 +30736,7 @@
                 </a:solidFill>
                 <a:latin typeface="Calibri"/>
               </a:rPr>
-              <a:t>3 / 34</a:t>
+              <a:t>3 / 36</a:t>
             </a:r>
           </a:p>
         </p:txBody>
@@ -31456,7 +31458,7 @@
                 </a:solidFill>
                 <a:latin typeface="Calibri"/>
               </a:rPr>
-              <a:t>One real `/scaffold` command bootstraps a runtime where 23 skills act as virtual commands. Keeps context cheap and discovery progressive.</a:t>
+              <a:t>One real `/scaffold` command bootstraps a runtime where 25 skills act as virtual commands. Keeps context cheap and discovery progressive.</a:t>
             </a:r>
           </a:p>
         </p:txBody>
@@ -31949,7 +31951,7 @@
                 </a:solidFill>
                 <a:latin typeface="Calibri"/>
               </a:rPr>
-              <a:t>30 / 34</a:t>
+              <a:t>30 / 36</a:t>
             </a:r>
           </a:p>
         </p:txBody>
@@ -32185,7 +32187,7 @@
               </a:defRPr>
             </a:pPr>
             <a:r>
-              <a:t>31 / 34</a:t>
+              <a:t>31 / 36</a:t>
             </a:r>
           </a:p>
         </p:txBody>
@@ -33139,7 +33141,7 @@
               </a:defRPr>
             </a:pPr>
             <a:r>
-              <a:t>32 / 34</a:t>
+              <a:t>32 / 36</a:t>
             </a:r>
           </a:p>
         </p:txBody>
@@ -33972,7 +33974,7 @@
               </a:defRPr>
             </a:pPr>
             <a:r>
-              <a:t>33 / 34</a:t>
+              <a:t>33 / 36</a:t>
             </a:r>
           </a:p>
         </p:txBody>
@@ -34526,7 +34528,1408 @@
               </a:defRPr>
             </a:pPr>
             <a:r>
-              <a:t>34 / 34</a:t>
+              <a:t>34 / 36</a:t>
+            </a:r>
+          </a:p>
+        </p:txBody>
+      </p:sp>
+    </p:spTree>
+  </p:cSld>
+  <p:clrMapOvr>
+    <a:masterClrMapping/>
+  </p:clrMapOvr>
+</p:sld>
+</file>
+
+<file path=ppt/slides/slide35.xml><?xml version="1.0" encoding="utf-8"?>
+<p:sld xmlns:a="http://schemas.openxmlformats.org/drawingml/2006/main" xmlns:p="http://schemas.openxmlformats.org/presentationml/2006/main" xmlns:r="http://schemas.openxmlformats.org/officeDocument/2006/relationships">
+  <p:cSld>
+    <p:spTree>
+      <p:nvGrpSpPr>
+        <p:cNvPr id="1" name=""/>
+        <p:cNvGrpSpPr/>
+        <p:nvPr/>
+      </p:nvGrpSpPr>
+      <p:grpSpPr/>
+      <p:sp>
+        <p:nvSpPr>
+          <p:cNvPr id="2" name="TextBox 1"/>
+          <p:cNvSpPr txBox="1"/>
+          <p:nvPr/>
+        </p:nvSpPr>
+        <p:spPr>
+          <a:xfrm>
+            <a:off x="502920" y="320040"/>
+            <a:ext cx="11155680" cy="502920"/>
+          </a:xfrm>
+          <a:prstGeom prst="rect">
+            <a:avLst/>
+          </a:prstGeom>
+          <a:noFill/>
+        </p:spPr>
+        <p:txBody>
+          <a:bodyPr wrap="none">
+            <a:spAutoFit/>
+          </a:bodyPr>
+          <a:lstStyle/>
+          <a:p>
+            <a:pPr>
+              <a:defRPr sz="2700" b="1">
+                <a:solidFill>
+                  <a:srgbClr val="111827"/>
+                </a:solidFill>
+              </a:defRPr>
+            </a:pPr>
+            <a:r>
+              <a:t>Graph-Grounded Brownfield Discovery</a:t>
+            </a:r>
+          </a:p>
+        </p:txBody>
+      </p:sp>
+      <p:sp>
+        <p:nvSpPr>
+          <p:cNvPr id="3" name="TextBox 2"/>
+          <p:cNvSpPr txBox="1"/>
+          <p:nvPr/>
+        </p:nvSpPr>
+        <p:spPr>
+          <a:xfrm>
+            <a:off x="530352" y="841248"/>
+            <a:ext cx="10789920" cy="320040"/>
+          </a:xfrm>
+          <a:prstGeom prst="rect">
+            <a:avLst/>
+          </a:prstGeom>
+          <a:noFill/>
+        </p:spPr>
+        <p:txBody>
+          <a:bodyPr wrap="none">
+            <a:spAutoFit/>
+          </a:bodyPr>
+          <a:lstStyle/>
+          <a:p>
+            <a:pPr>
+              <a:defRPr sz="1250">
+                <a:solidFill>
+                  <a:srgbClr val="4B5563"/>
+                </a:solidFill>
+              </a:defRPr>
+            </a:pPr>
+            <a:r>
+              <a:t>v4 ports the enriched v3 brownfield flow: code graph first, narrative second.</a:t>
+            </a:r>
+          </a:p>
+        </p:txBody>
+      </p:sp>
+      <p:sp>
+        <p:nvSpPr>
+          <p:cNvPr id="4" name="Rounded Rectangle 3"/>
+          <p:cNvSpPr/>
+          <p:nvPr/>
+        </p:nvSpPr>
+        <p:spPr>
+          <a:xfrm>
+            <a:off x="502920" y="1508760"/>
+            <a:ext cx="1874519" cy="3246120"/>
+          </a:xfrm>
+          <a:prstGeom prst="roundRect">
+            <a:avLst/>
+          </a:prstGeom>
+          <a:solidFill>
+            <a:srgbClr val="EFF6FF"/>
+          </a:solidFill>
+          <a:ln w="13970">
+            <a:solidFill>
+              <a:srgbClr val="3B82F6"/>
+            </a:solidFill>
+          </a:ln>
+        </p:spPr>
+        <p:style>
+          <a:lnRef idx="1">
+            <a:schemeClr val="accent1"/>
+          </a:lnRef>
+          <a:fillRef idx="3">
+            <a:schemeClr val="accent1"/>
+          </a:fillRef>
+          <a:effectRef idx="2">
+            <a:schemeClr val="accent1"/>
+          </a:effectRef>
+          <a:fontRef idx="minor">
+            <a:schemeClr val="lt1"/>
+          </a:fontRef>
+        </p:style>
+        <p:txBody>
+          <a:bodyPr rtlCol="0" anchor="t" lIns="109728" rIns="109728" tIns="73152"/>
+          <a:lstStyle/>
+          <a:p>
+            <a:pPr algn="ctr">
+              <a:defRPr sz="1300" b="1">
+                <a:solidFill>
+                  <a:srgbClr val="0F172A"/>
+                </a:solidFill>
+              </a:defRPr>
+            </a:pPr>
+            <a:r>
+              <a:t>/brownfield</a:t>
+            </a:r>
+          </a:p>
+          <a:p>
+            <a:pPr>
+              <a:spcBef>
+                <a:spcPts val="300"/>
+              </a:spcBef>
+              <a:defRPr sz="930">
+                <a:solidFill>
+                  <a:srgbClr val="334155"/>
+                </a:solidFill>
+              </a:defRPr>
+            </a:pPr>
+            <a:r>
+              <a:t>Entry point for existing-codebase work</a:t>
+            </a:r>
+          </a:p>
+          <a:p>
+            <a:pPr>
+              <a:spcBef>
+                <a:spcPts val="300"/>
+              </a:spcBef>
+              <a:defRPr sz="930">
+                <a:solidFill>
+                  <a:srgbClr val="334155"/>
+                </a:solidFill>
+              </a:defRPr>
+            </a:pPr>
+            <a:r>
+              <a:t>Read-only except brownfield docs</a:t>
+            </a:r>
+          </a:p>
+        </p:txBody>
+      </p:sp>
+      <p:cxnSp>
+        <p:nvCxnSpPr>
+          <p:cNvPr id="5" name="Connector 4"/>
+          <p:cNvCxnSpPr/>
+          <p:nvPr/>
+        </p:nvCxnSpPr>
+        <p:spPr>
+          <a:xfrm>
+            <a:off x="2377439" y="3063240"/>
+            <a:ext cx="411481" cy="0"/>
+          </a:xfrm>
+          <a:prstGeom prst="line">
+            <a:avLst/>
+          </a:prstGeom>
+          <a:ln w="19050">
+            <a:solidFill>
+              <a:srgbClr val="475569"/>
+            </a:solidFill>
+          </a:ln>
+        </p:spPr>
+        <p:style>
+          <a:lnRef idx="2">
+            <a:schemeClr val="accent1"/>
+          </a:lnRef>
+          <a:fillRef idx="0">
+            <a:schemeClr val="accent1"/>
+          </a:fillRef>
+          <a:effectRef idx="1">
+            <a:schemeClr val="accent1"/>
+          </a:effectRef>
+          <a:fontRef idx="minor">
+            <a:schemeClr val="tx1"/>
+          </a:fontRef>
+        </p:style>
+      </p:cxnSp>
+      <p:sp>
+        <p:nvSpPr>
+          <p:cNvPr id="6" name="Rounded Rectangle 5"/>
+          <p:cNvSpPr/>
+          <p:nvPr/>
+        </p:nvSpPr>
+        <p:spPr>
+          <a:xfrm>
+            <a:off x="2788920" y="1508760"/>
+            <a:ext cx="1874519" cy="3246120"/>
+          </a:xfrm>
+          <a:prstGeom prst="roundRect">
+            <a:avLst/>
+          </a:prstGeom>
+          <a:solidFill>
+            <a:srgbClr val="FFFBEB"/>
+          </a:solidFill>
+          <a:ln w="13970">
+            <a:solidFill>
+              <a:srgbClr val="F59E0B"/>
+            </a:solidFill>
+          </a:ln>
+        </p:spPr>
+        <p:style>
+          <a:lnRef idx="1">
+            <a:schemeClr val="accent1"/>
+          </a:lnRef>
+          <a:fillRef idx="3">
+            <a:schemeClr val="accent1"/>
+          </a:fillRef>
+          <a:effectRef idx="2">
+            <a:schemeClr val="accent1"/>
+          </a:effectRef>
+          <a:fontRef idx="minor">
+            <a:schemeClr val="lt1"/>
+          </a:fontRef>
+        </p:style>
+        <p:txBody>
+          <a:bodyPr rtlCol="0" anchor="t" lIns="109728" rIns="109728" tIns="73152"/>
+          <a:lstStyle/>
+          <a:p>
+            <a:pPr algn="ctr">
+              <a:defRPr sz="1300" b="1">
+                <a:solidFill>
+                  <a:srgbClr val="0F172A"/>
+                </a:solidFill>
+              </a:defRPr>
+            </a:pPr>
+            <a:r>
+              <a:t>/code-map</a:t>
+            </a:r>
+          </a:p>
+          <a:p>
+            <a:pPr>
+              <a:spcBef>
+                <a:spcPts val="300"/>
+              </a:spcBef>
+              <a:defRPr sz="930">
+                <a:solidFill>
+                  <a:srgbClr val="334155"/>
+                </a:solidFill>
+              </a:defRPr>
+            </a:pPr>
+            <a:r>
+              <a:t>Producer chain: graphify, hex-graph, vendored Node</a:t>
+            </a:r>
+          </a:p>
+          <a:p>
+            <a:pPr>
+              <a:spcBef>
+                <a:spcPts val="300"/>
+              </a:spcBef>
+              <a:defRPr sz="930">
+                <a:solidFill>
+                  <a:srgbClr val="334155"/>
+                </a:solidFill>
+              </a:defRPr>
+            </a:pPr>
+            <a:r>
+              <a:t>Writes deterministic graph artifacts</a:t>
+            </a:r>
+          </a:p>
+        </p:txBody>
+      </p:sp>
+      <p:cxnSp>
+        <p:nvCxnSpPr>
+          <p:cNvPr id="7" name="Connector 6"/>
+          <p:cNvCxnSpPr/>
+          <p:nvPr/>
+        </p:nvCxnSpPr>
+        <p:spPr>
+          <a:xfrm>
+            <a:off x="4663440" y="3063240"/>
+            <a:ext cx="411480" cy="0"/>
+          </a:xfrm>
+          <a:prstGeom prst="line">
+            <a:avLst/>
+          </a:prstGeom>
+          <a:ln w="19050">
+            <a:solidFill>
+              <a:srgbClr val="475569"/>
+            </a:solidFill>
+          </a:ln>
+        </p:spPr>
+        <p:style>
+          <a:lnRef idx="2">
+            <a:schemeClr val="accent1"/>
+          </a:lnRef>
+          <a:fillRef idx="0">
+            <a:schemeClr val="accent1"/>
+          </a:fillRef>
+          <a:effectRef idx="1">
+            <a:schemeClr val="accent1"/>
+          </a:effectRef>
+          <a:fontRef idx="minor">
+            <a:schemeClr val="tx1"/>
+          </a:fontRef>
+        </p:style>
+      </p:cxnSp>
+      <p:sp>
+        <p:nvSpPr>
+          <p:cNvPr id="8" name="Rounded Rectangle 7"/>
+          <p:cNvSpPr/>
+          <p:nvPr/>
+        </p:nvSpPr>
+        <p:spPr>
+          <a:xfrm>
+            <a:off x="5074920" y="1508760"/>
+            <a:ext cx="1874519" cy="3246120"/>
+          </a:xfrm>
+          <a:prstGeom prst="roundRect">
+            <a:avLst/>
+          </a:prstGeom>
+          <a:solidFill>
+            <a:srgbClr val="F0FDF4"/>
+          </a:solidFill>
+          <a:ln w="13970">
+            <a:solidFill>
+              <a:srgbClr val="22C55E"/>
+            </a:solidFill>
+          </a:ln>
+        </p:spPr>
+        <p:style>
+          <a:lnRef idx="1">
+            <a:schemeClr val="accent1"/>
+          </a:lnRef>
+          <a:fillRef idx="3">
+            <a:schemeClr val="accent1"/>
+          </a:fillRef>
+          <a:effectRef idx="2">
+            <a:schemeClr val="accent1"/>
+          </a:effectRef>
+          <a:fontRef idx="minor">
+            <a:schemeClr val="lt1"/>
+          </a:fontRef>
+        </p:style>
+        <p:txBody>
+          <a:bodyPr rtlCol="0" anchor="t" lIns="109728" rIns="109728" tIns="73152"/>
+          <a:lstStyle/>
+          <a:p>
+            <a:pPr algn="ctr">
+              <a:defRPr sz="1300" b="1">
+                <a:solidFill>
+                  <a:srgbClr val="0F172A"/>
+                </a:solidFill>
+              </a:defRPr>
+            </a:pPr>
+            <a:r>
+              <a:t>Graph artifacts</a:t>
+            </a:r>
+          </a:p>
+          <a:p>
+            <a:pPr>
+              <a:spcBef>
+                <a:spcPts val="300"/>
+              </a:spcBef>
+              <a:defRPr sz="930">
+                <a:solidFill>
+                  <a:srgbClr val="334155"/>
+                </a:solidFill>
+              </a:defRPr>
+            </a:pPr>
+            <a:r>
+              <a:t>code-graph.json + meta</a:t>
+            </a:r>
+          </a:p>
+          <a:p>
+            <a:pPr>
+              <a:spcBef>
+                <a:spcPts val="300"/>
+              </a:spcBef>
+              <a:defRPr sz="930">
+                <a:solidFill>
+                  <a:srgbClr val="334155"/>
+                </a:solidFill>
+              </a:defRPr>
+            </a:pPr>
+            <a:r>
+              <a:t>dependency-graph.md</a:t>
+            </a:r>
+          </a:p>
+          <a:p>
+            <a:pPr>
+              <a:spcBef>
+                <a:spcPts val="300"/>
+              </a:spcBef>
+              <a:defRPr sz="930">
+                <a:solidFill>
+                  <a:srgbClr val="334155"/>
+                </a:solidFill>
+              </a:defRPr>
+            </a:pPr>
+            <a:r>
+              <a:t>coupling-report.md</a:t>
+            </a:r>
+          </a:p>
+        </p:txBody>
+      </p:sp>
+      <p:cxnSp>
+        <p:nvCxnSpPr>
+          <p:cNvPr id="9" name="Connector 8"/>
+          <p:cNvCxnSpPr/>
+          <p:nvPr/>
+        </p:nvCxnSpPr>
+        <p:spPr>
+          <a:xfrm>
+            <a:off x="6949440" y="3063240"/>
+            <a:ext cx="411480" cy="0"/>
+          </a:xfrm>
+          <a:prstGeom prst="line">
+            <a:avLst/>
+          </a:prstGeom>
+          <a:ln w="19050">
+            <a:solidFill>
+              <a:srgbClr val="475569"/>
+            </a:solidFill>
+          </a:ln>
+        </p:spPr>
+        <p:style>
+          <a:lnRef idx="2">
+            <a:schemeClr val="accent1"/>
+          </a:lnRef>
+          <a:fillRef idx="0">
+            <a:schemeClr val="accent1"/>
+          </a:fillRef>
+          <a:effectRef idx="1">
+            <a:schemeClr val="accent1"/>
+          </a:effectRef>
+          <a:fontRef idx="minor">
+            <a:schemeClr val="tx1"/>
+          </a:fontRef>
+        </p:style>
+      </p:cxnSp>
+      <p:sp>
+        <p:nvSpPr>
+          <p:cNvPr id="10" name="Rounded Rectangle 9"/>
+          <p:cNvSpPr/>
+          <p:nvPr/>
+        </p:nvSpPr>
+        <p:spPr>
+          <a:xfrm>
+            <a:off x="7360920" y="1508760"/>
+            <a:ext cx="1874519" cy="3246120"/>
+          </a:xfrm>
+          <a:prstGeom prst="roundRect">
+            <a:avLst/>
+          </a:prstGeom>
+          <a:solidFill>
+            <a:srgbClr val="F5F3FF"/>
+          </a:solidFill>
+          <a:ln w="13970">
+            <a:solidFill>
+              <a:srgbClr val="8B5CF6"/>
+            </a:solidFill>
+          </a:ln>
+        </p:spPr>
+        <p:style>
+          <a:lnRef idx="1">
+            <a:schemeClr val="accent1"/>
+          </a:lnRef>
+          <a:fillRef idx="3">
+            <a:schemeClr val="accent1"/>
+          </a:fillRef>
+          <a:effectRef idx="2">
+            <a:schemeClr val="accent1"/>
+          </a:effectRef>
+          <a:fontRef idx="minor">
+            <a:schemeClr val="lt1"/>
+          </a:fontRef>
+        </p:style>
+        <p:txBody>
+          <a:bodyPr rtlCol="0" anchor="t" lIns="109728" rIns="109728" tIns="73152"/>
+          <a:lstStyle/>
+          <a:p>
+            <a:pPr algn="ctr">
+              <a:defRPr sz="1300" b="1">
+                <a:solidFill>
+                  <a:srgbClr val="0F172A"/>
+                </a:solidFill>
+              </a:defRPr>
+            </a:pPr>
+            <a:r>
+              <a:t>Evidence maps</a:t>
+            </a:r>
+          </a:p>
+          <a:p>
+            <a:pPr>
+              <a:spcBef>
+                <a:spcPts val="300"/>
+              </a:spcBef>
+              <a:defRPr sz="930">
+                <a:solidFill>
+                  <a:srgbClr val="334155"/>
+                </a:solidFill>
+              </a:defRPr>
+            </a:pPr>
+            <a:r>
+              <a:t>architecture-map.md cites edges</a:t>
+            </a:r>
+          </a:p>
+          <a:p>
+            <a:pPr>
+              <a:spcBef>
+                <a:spcPts val="300"/>
+              </a:spcBef>
+              <a:defRPr sz="930">
+                <a:solidFill>
+                  <a:srgbClr val="334155"/>
+                </a:solidFill>
+              </a:defRPr>
+            </a:pPr>
+            <a:r>
+              <a:t>risk-map.md cites hubs/cycles</a:t>
+            </a:r>
+          </a:p>
+          <a:p>
+            <a:pPr>
+              <a:spcBef>
+                <a:spcPts val="300"/>
+              </a:spcBef>
+              <a:defRPr sz="930">
+                <a:solidFill>
+                  <a:srgbClr val="334155"/>
+                </a:solidFill>
+              </a:defRPr>
+            </a:pPr>
+            <a:r>
+              <a:t>change-strategy.md chooses lane</a:t>
+            </a:r>
+          </a:p>
+        </p:txBody>
+      </p:sp>
+      <p:cxnSp>
+        <p:nvCxnSpPr>
+          <p:cNvPr id="11" name="Connector 10"/>
+          <p:cNvCxnSpPr/>
+          <p:nvPr/>
+        </p:nvCxnSpPr>
+        <p:spPr>
+          <a:xfrm>
+            <a:off x="9235440" y="3063240"/>
+            <a:ext cx="411480" cy="0"/>
+          </a:xfrm>
+          <a:prstGeom prst="line">
+            <a:avLst/>
+          </a:prstGeom>
+          <a:ln w="19050">
+            <a:solidFill>
+              <a:srgbClr val="475569"/>
+            </a:solidFill>
+          </a:ln>
+        </p:spPr>
+        <p:style>
+          <a:lnRef idx="2">
+            <a:schemeClr val="accent1"/>
+          </a:lnRef>
+          <a:fillRef idx="0">
+            <a:schemeClr val="accent1"/>
+          </a:fillRef>
+          <a:effectRef idx="1">
+            <a:schemeClr val="accent1"/>
+          </a:effectRef>
+          <a:fontRef idx="minor">
+            <a:schemeClr val="tx1"/>
+          </a:fontRef>
+        </p:style>
+      </p:cxnSp>
+      <p:sp>
+        <p:nvSpPr>
+          <p:cNvPr id="12" name="Rounded Rectangle 11"/>
+          <p:cNvSpPr/>
+          <p:nvPr/>
+        </p:nvSpPr>
+        <p:spPr>
+          <a:xfrm>
+            <a:off x="9646920" y="1508760"/>
+            <a:ext cx="1874519" cy="3246120"/>
+          </a:xfrm>
+          <a:prstGeom prst="roundRect">
+            <a:avLst/>
+          </a:prstGeom>
+          <a:solidFill>
+            <a:srgbClr val="F8FAFC"/>
+          </a:solidFill>
+          <a:ln w="13970">
+            <a:solidFill>
+              <a:srgbClr val="94A3B8"/>
+            </a:solidFill>
+          </a:ln>
+        </p:spPr>
+        <p:style>
+          <a:lnRef idx="1">
+            <a:schemeClr val="accent1"/>
+          </a:lnRef>
+          <a:fillRef idx="3">
+            <a:schemeClr val="accent1"/>
+          </a:fillRef>
+          <a:effectRef idx="2">
+            <a:schemeClr val="accent1"/>
+          </a:effectRef>
+          <a:fontRef idx="minor">
+            <a:schemeClr val="lt1"/>
+          </a:fontRef>
+        </p:style>
+        <p:txBody>
+          <a:bodyPr rtlCol="0" anchor="t" lIns="109728" rIns="109728" tIns="73152"/>
+          <a:lstStyle/>
+          <a:p>
+            <a:pPr algn="ctr">
+              <a:defRPr sz="1300" b="1">
+                <a:solidFill>
+                  <a:srgbClr val="0F172A"/>
+                </a:solidFill>
+              </a:defRPr>
+            </a:pPr>
+            <a:r>
+              <a:t>/seam-finder</a:t>
+            </a:r>
+          </a:p>
+          <a:p>
+            <a:pPr>
+              <a:spcBef>
+                <a:spcPts val="300"/>
+              </a:spcBef>
+              <a:defRPr sz="930">
+                <a:solidFill>
+                  <a:srgbClr val="334155"/>
+                </a:solidFill>
+              </a:defRPr>
+            </a:pPr>
+            <a:r>
+              <a:t>Ranks safe cut-points for a goal</a:t>
+            </a:r>
+          </a:p>
+          <a:p>
+            <a:pPr>
+              <a:spcBef>
+                <a:spcPts val="300"/>
+              </a:spcBef>
+              <a:defRPr sz="930">
+                <a:solidFill>
+                  <a:srgbClr val="334155"/>
+                </a:solidFill>
+              </a:defRPr>
+            </a:pPr>
+            <a:r>
+              <a:t>Writes seams-&lt;goal&gt;.md</a:t>
+            </a:r>
+          </a:p>
+        </p:txBody>
+      </p:sp>
+      <p:sp>
+        <p:nvSpPr>
+          <p:cNvPr id="13" name="Rounded Rectangle 12"/>
+          <p:cNvSpPr/>
+          <p:nvPr/>
+        </p:nvSpPr>
+        <p:spPr>
+          <a:xfrm>
+            <a:off x="868680" y="5257800"/>
+            <a:ext cx="10378440" cy="594360"/>
+          </a:xfrm>
+          <a:prstGeom prst="roundRect">
+            <a:avLst/>
+          </a:prstGeom>
+          <a:solidFill>
+            <a:srgbClr val="FFFFFF"/>
+          </a:solidFill>
+          <a:ln w="13970">
+            <a:solidFill>
+              <a:srgbClr val="94A3B8"/>
+            </a:solidFill>
+          </a:ln>
+        </p:spPr>
+        <p:style>
+          <a:lnRef idx="1">
+            <a:schemeClr val="accent1"/>
+          </a:lnRef>
+          <a:fillRef idx="3">
+            <a:schemeClr val="accent1"/>
+          </a:fillRef>
+          <a:effectRef idx="2">
+            <a:schemeClr val="accent1"/>
+          </a:effectRef>
+          <a:fontRef idx="minor">
+            <a:schemeClr val="lt1"/>
+          </a:fontRef>
+        </p:style>
+        <p:txBody>
+          <a:bodyPr rtlCol="0" anchor="t" lIns="109728" rIns="109728" tIns="73152"/>
+          <a:lstStyle/>
+          <a:p>
+            <a:pPr algn="ctr">
+              <a:defRPr sz="1300" b="1">
+                <a:solidFill>
+                  <a:srgbClr val="0F172A"/>
+                </a:solidFill>
+              </a:defRPr>
+            </a:pPr>
+            <a:r>
+              <a:t>Agent contract</a:t>
+            </a:r>
+          </a:p>
+          <a:p>
+            <a:pPr>
+              <a:spcBef>
+                <a:spcPts val="300"/>
+              </a:spcBef>
+              <a:defRPr sz="1000">
+                <a:solidFill>
+                  <a:srgbClr val="334155"/>
+                </a:solidFill>
+              </a:defRPr>
+            </a:pPr>
+            <a:r>
+              <a:t>Any brownfield claim such as "module X depends on Y" must cite code-graph.json edge evidence. Refactor targets read coupling-report.md and seams-&lt;goal&gt;.md.</a:t>
+            </a:r>
+          </a:p>
+        </p:txBody>
+      </p:sp>
+      <p:sp>
+        <p:nvSpPr>
+          <p:cNvPr id="14" name="TextBox 13"/>
+          <p:cNvSpPr txBox="1"/>
+          <p:nvPr/>
+        </p:nvSpPr>
+        <p:spPr>
+          <a:xfrm>
+            <a:off x="411480" y="6446520"/>
+            <a:ext cx="6766560" cy="228600"/>
+          </a:xfrm>
+          <a:prstGeom prst="rect">
+            <a:avLst/>
+          </a:prstGeom>
+          <a:noFill/>
+        </p:spPr>
+        <p:txBody>
+          <a:bodyPr wrap="none">
+            <a:spAutoFit/>
+          </a:bodyPr>
+          <a:lstStyle/>
+          <a:p>
+            <a:pPr>
+              <a:defRPr sz="850">
+                <a:solidFill>
+                  <a:srgbClr val="566070"/>
+                </a:solidFill>
+              </a:defRPr>
+            </a:pPr>
+            <a:r>
+              <a:t>Claude Harness Engine v1.1.4   ·   Graph-Grounded Brownfield Discovery</a:t>
+            </a:r>
+          </a:p>
+        </p:txBody>
+      </p:sp>
+      <p:sp>
+        <p:nvSpPr>
+          <p:cNvPr id="15" name="TextBox 14"/>
+          <p:cNvSpPr txBox="1"/>
+          <p:nvPr/>
+        </p:nvSpPr>
+        <p:spPr>
+          <a:xfrm>
+            <a:off x="10972800" y="6446520"/>
+            <a:ext cx="731520" cy="228600"/>
+          </a:xfrm>
+          <a:prstGeom prst="rect">
+            <a:avLst/>
+          </a:prstGeom>
+          <a:noFill/>
+        </p:spPr>
+        <p:txBody>
+          <a:bodyPr wrap="none">
+            <a:spAutoFit/>
+          </a:bodyPr>
+          <a:lstStyle/>
+          <a:p>
+            <a:pPr algn="r">
+              <a:defRPr sz="850">
+                <a:solidFill>
+                  <a:srgbClr val="566070"/>
+                </a:solidFill>
+              </a:defRPr>
+            </a:pPr>
+            <a:r>
+              <a:t>35 / 36</a:t>
+            </a:r>
+          </a:p>
+        </p:txBody>
+      </p:sp>
+    </p:spTree>
+  </p:cSld>
+  <p:clrMapOvr>
+    <a:masterClrMapping/>
+  </p:clrMapOvr>
+</p:sld>
+</file>
+
+<file path=ppt/slides/slide36.xml><?xml version="1.0" encoding="utf-8"?>
+<p:sld xmlns:a="http://schemas.openxmlformats.org/drawingml/2006/main" xmlns:p="http://schemas.openxmlformats.org/presentationml/2006/main" xmlns:r="http://schemas.openxmlformats.org/officeDocument/2006/relationships">
+  <p:cSld>
+    <p:spTree>
+      <p:nvGrpSpPr>
+        <p:cNvPr id="1" name=""/>
+        <p:cNvGrpSpPr/>
+        <p:nvPr/>
+      </p:nvGrpSpPr>
+      <p:grpSpPr/>
+      <p:sp>
+        <p:nvSpPr>
+          <p:cNvPr id="2" name="TextBox 1"/>
+          <p:cNvSpPr txBox="1"/>
+          <p:nvPr/>
+        </p:nvSpPr>
+        <p:spPr>
+          <a:xfrm>
+            <a:off x="502920" y="320040"/>
+            <a:ext cx="11155680" cy="502920"/>
+          </a:xfrm>
+          <a:prstGeom prst="rect">
+            <a:avLst/>
+          </a:prstGeom>
+          <a:noFill/>
+        </p:spPr>
+        <p:txBody>
+          <a:bodyPr wrap="none">
+            <a:spAutoFit/>
+          </a:bodyPr>
+          <a:lstStyle/>
+          <a:p>
+            <a:pPr>
+              <a:defRPr sz="2700" b="1">
+                <a:solidFill>
+                  <a:srgbClr val="111827"/>
+                </a:solidFill>
+              </a:defRPr>
+            </a:pPr>
+            <a:r>
+              <a:t>Brownfield Seam Scoring: Where Should the Agent Cut?</a:t>
+            </a:r>
+          </a:p>
+        </p:txBody>
+      </p:sp>
+      <p:sp>
+        <p:nvSpPr>
+          <p:cNvPr id="3" name="TextBox 2"/>
+          <p:cNvSpPr txBox="1"/>
+          <p:nvPr/>
+        </p:nvSpPr>
+        <p:spPr>
+          <a:xfrm>
+            <a:off x="530352" y="841248"/>
+            <a:ext cx="10789920" cy="320040"/>
+          </a:xfrm>
+          <a:prstGeom prst="rect">
+            <a:avLst/>
+          </a:prstGeom>
+          <a:noFill/>
+        </p:spPr>
+        <p:txBody>
+          <a:bodyPr wrap="none">
+            <a:spAutoFit/>
+          </a:bodyPr>
+          <a:lstStyle/>
+          <a:p>
+            <a:pPr>
+              <a:defRPr sz="1250">
+                <a:solidFill>
+                  <a:srgbClr val="4B5563"/>
+                </a:solidFill>
+              </a:defRPr>
+            </a:pPr>
+            <a:r>
+              <a:t>/seam-finder turns graph structure plus a goal into ranked extension/refactor candidates.</a:t>
+            </a:r>
+          </a:p>
+        </p:txBody>
+      </p:sp>
+      <p:sp>
+        <p:nvSpPr>
+          <p:cNvPr id="4" name="Rounded Rectangle 3"/>
+          <p:cNvSpPr/>
+          <p:nvPr/>
+        </p:nvSpPr>
+        <p:spPr>
+          <a:xfrm>
+            <a:off x="594360" y="1325880"/>
+            <a:ext cx="2743200" cy="4114800"/>
+          </a:xfrm>
+          <a:prstGeom prst="roundRect">
+            <a:avLst/>
+          </a:prstGeom>
+          <a:solidFill>
+            <a:srgbClr val="EFF6FF"/>
+          </a:solidFill>
+          <a:ln w="13970">
+            <a:solidFill>
+              <a:srgbClr val="3B82F6"/>
+            </a:solidFill>
+          </a:ln>
+        </p:spPr>
+        <p:style>
+          <a:lnRef idx="1">
+            <a:schemeClr val="accent1"/>
+          </a:lnRef>
+          <a:fillRef idx="3">
+            <a:schemeClr val="accent1"/>
+          </a:fillRef>
+          <a:effectRef idx="2">
+            <a:schemeClr val="accent1"/>
+          </a:effectRef>
+          <a:fontRef idx="minor">
+            <a:schemeClr val="lt1"/>
+          </a:fontRef>
+        </p:style>
+        <p:txBody>
+          <a:bodyPr rtlCol="0" anchor="t" lIns="109728" rIns="109728" tIns="73152"/>
+          <a:lstStyle/>
+          <a:p>
+            <a:pPr algn="ctr">
+              <a:defRPr sz="1300" b="1">
+                <a:solidFill>
+                  <a:srgbClr val="0F172A"/>
+                </a:solidFill>
+              </a:defRPr>
+            </a:pPr>
+            <a:r>
+              <a:t>Inputs</a:t>
+            </a:r>
+          </a:p>
+          <a:p>
+            <a:pPr>
+              <a:spcBef>
+                <a:spcPts val="300"/>
+              </a:spcBef>
+              <a:defRPr sz="1019">
+                <a:solidFill>
+                  <a:srgbClr val="334155"/>
+                </a:solidFill>
+              </a:defRPr>
+            </a:pPr>
+            <a:r>
+              <a:t>code-graph.json</a:t>
+            </a:r>
+          </a:p>
+          <a:p>
+            <a:pPr>
+              <a:spcBef>
+                <a:spcPts val="300"/>
+              </a:spcBef>
+              <a:defRPr sz="1019">
+                <a:solidFill>
+                  <a:srgbClr val="334155"/>
+                </a:solidFill>
+              </a:defRPr>
+            </a:pPr>
+            <a:r>
+              <a:t>coupling-report.md</a:t>
+            </a:r>
+          </a:p>
+          <a:p>
+            <a:pPr>
+              <a:spcBef>
+                <a:spcPts val="300"/>
+              </a:spcBef>
+              <a:defRPr sz="1019">
+                <a:solidFill>
+                  <a:srgbClr val="334155"/>
+                </a:solidFill>
+              </a:defRPr>
+            </a:pPr>
+            <a:r>
+              <a:t>goal phrase</a:t>
+            </a:r>
+          </a:p>
+          <a:p>
+            <a:pPr>
+              <a:spcBef>
+                <a:spcPts val="300"/>
+              </a:spcBef>
+              <a:defRPr sz="1019">
+                <a:solidFill>
+                  <a:srgbClr val="334155"/>
+                </a:solidFill>
+              </a:defRPr>
+            </a:pPr>
+            <a:r>
+              <a:t>optional graphify / hex-graph fidelity</a:t>
+            </a:r>
+          </a:p>
+        </p:txBody>
+      </p:sp>
+      <p:sp>
+        <p:nvSpPr>
+          <p:cNvPr id="5" name="Rounded Rectangle 4"/>
+          <p:cNvSpPr/>
+          <p:nvPr/>
+        </p:nvSpPr>
+        <p:spPr>
+          <a:xfrm>
+            <a:off x="3657600" y="1325880"/>
+            <a:ext cx="4206240" cy="4114800"/>
+          </a:xfrm>
+          <a:prstGeom prst="roundRect">
+            <a:avLst/>
+          </a:prstGeom>
+          <a:solidFill>
+            <a:srgbClr val="FFFBEB"/>
+          </a:solidFill>
+          <a:ln w="13970">
+            <a:solidFill>
+              <a:srgbClr val="F59E0B"/>
+            </a:solidFill>
+          </a:ln>
+        </p:spPr>
+        <p:style>
+          <a:lnRef idx="1">
+            <a:schemeClr val="accent1"/>
+          </a:lnRef>
+          <a:fillRef idx="3">
+            <a:schemeClr val="accent1"/>
+          </a:fillRef>
+          <a:effectRef idx="2">
+            <a:schemeClr val="accent1"/>
+          </a:effectRef>
+          <a:fontRef idx="minor">
+            <a:schemeClr val="lt1"/>
+          </a:fontRef>
+        </p:style>
+        <p:txBody>
+          <a:bodyPr rtlCol="0" anchor="t" lIns="109728" rIns="109728" tIns="73152"/>
+          <a:lstStyle/>
+          <a:p>
+            <a:pPr algn="ctr">
+              <a:defRPr sz="1300" b="1">
+                <a:solidFill>
+                  <a:srgbClr val="0F172A"/>
+                </a:solidFill>
+              </a:defRPr>
+            </a:pPr>
+            <a:r>
+              <a:t>Score model</a:t>
+            </a:r>
+          </a:p>
+          <a:p>
+            <a:pPr>
+              <a:spcBef>
+                <a:spcPts val="300"/>
+              </a:spcBef>
+              <a:defRPr sz="1019">
+                <a:solidFill>
+                  <a:srgbClr val="334155"/>
+                </a:solidFill>
+              </a:defRPr>
+            </a:pPr>
+            <a:r>
+              <a:t>Observable boundary 0.4</a:t>
+            </a:r>
+          </a:p>
+          <a:p>
+            <a:pPr>
+              <a:spcBef>
+                <a:spcPts val="300"/>
+              </a:spcBef>
+              <a:defRPr sz="1019">
+                <a:solidFill>
+                  <a:srgbClr val="334155"/>
+                </a:solidFill>
+              </a:defRPr>
+            </a:pPr>
+            <a:r>
+              <a:t>Funnel score 0.4</a:t>
+            </a:r>
+          </a:p>
+          <a:p>
+            <a:pPr>
+              <a:spcBef>
+                <a:spcPts val="300"/>
+              </a:spcBef>
+              <a:defRPr sz="1019">
+                <a:solidFill>
+                  <a:srgbClr val="334155"/>
+                </a:solidFill>
+              </a:defRPr>
+            </a:pPr>
+            <a:r>
+              <a:t>Read/write asymmetry 0.2</a:t>
+            </a:r>
+          </a:p>
+          <a:p>
+            <a:pPr>
+              <a:spcBef>
+                <a:spcPts val="300"/>
+              </a:spcBef>
+              <a:defRPr sz="1019">
+                <a:solidFill>
+                  <a:srgbClr val="334155"/>
+                </a:solidFill>
+              </a:defRPr>
+            </a:pPr>
+            <a:r>
+              <a:t>Goal keyword bump x1.5</a:t>
+            </a:r>
+          </a:p>
+          <a:p>
+            <a:pPr>
+              <a:spcBef>
+                <a:spcPts val="300"/>
+              </a:spcBef>
+              <a:defRPr sz="1019">
+                <a:solidFill>
+                  <a:srgbClr val="334155"/>
+                </a:solidFill>
+              </a:defRPr>
+            </a:pPr>
+            <a:r>
+              <a:t>Tests/fixtures excluded by default</a:t>
+            </a:r>
+          </a:p>
+        </p:txBody>
+      </p:sp>
+      <p:sp>
+        <p:nvSpPr>
+          <p:cNvPr id="6" name="Rounded Rectangle 5"/>
+          <p:cNvSpPr/>
+          <p:nvPr/>
+        </p:nvSpPr>
+        <p:spPr>
+          <a:xfrm>
+            <a:off x="8183879" y="1325880"/>
+            <a:ext cx="3337560" cy="4114800"/>
+          </a:xfrm>
+          <a:prstGeom prst="roundRect">
+            <a:avLst/>
+          </a:prstGeom>
+          <a:solidFill>
+            <a:srgbClr val="F0FDF4"/>
+          </a:solidFill>
+          <a:ln w="13970">
+            <a:solidFill>
+              <a:srgbClr val="22C55E"/>
+            </a:solidFill>
+          </a:ln>
+        </p:spPr>
+        <p:style>
+          <a:lnRef idx="1">
+            <a:schemeClr val="accent1"/>
+          </a:lnRef>
+          <a:fillRef idx="3">
+            <a:schemeClr val="accent1"/>
+          </a:fillRef>
+          <a:effectRef idx="2">
+            <a:schemeClr val="accent1"/>
+          </a:effectRef>
+          <a:fontRef idx="minor">
+            <a:schemeClr val="lt1"/>
+          </a:fontRef>
+        </p:style>
+        <p:txBody>
+          <a:bodyPr rtlCol="0" anchor="t" lIns="109728" rIns="109728" tIns="73152"/>
+          <a:lstStyle/>
+          <a:p>
+            <a:pPr algn="ctr">
+              <a:defRPr sz="1300" b="1">
+                <a:solidFill>
+                  <a:srgbClr val="0F172A"/>
+                </a:solidFill>
+              </a:defRPr>
+            </a:pPr>
+            <a:r>
+              <a:t>Recommended action</a:t>
+            </a:r>
+          </a:p>
+          <a:p>
+            <a:pPr>
+              <a:spcBef>
+                <a:spcPts val="300"/>
+              </a:spcBef>
+              <a:defRPr sz="1019">
+                <a:solidFill>
+                  <a:srgbClr val="334155"/>
+                </a:solidFill>
+              </a:defRPr>
+            </a:pPr>
+            <a:r>
+              <a:t>extend existing seam</a:t>
+            </a:r>
+          </a:p>
+          <a:p>
+            <a:pPr>
+              <a:spcBef>
+                <a:spcPts val="300"/>
+              </a:spcBef>
+              <a:defRPr sz="1019">
+                <a:solidFill>
+                  <a:srgbClr val="334155"/>
+                </a:solidFill>
+              </a:defRPr>
+            </a:pPr>
+            <a:r>
+              <a:t>wrap a boundary</a:t>
+            </a:r>
+          </a:p>
+          <a:p>
+            <a:pPr>
+              <a:spcBef>
+                <a:spcPts val="300"/>
+              </a:spcBef>
+              <a:defRPr sz="1019">
+                <a:solidFill>
+                  <a:srgbClr val="334155"/>
+                </a:solidFill>
+              </a:defRPr>
+            </a:pPr>
+            <a:r>
+              <a:t>introduce adapter</a:t>
+            </a:r>
+          </a:p>
+          <a:p>
+            <a:pPr>
+              <a:spcBef>
+                <a:spcPts val="300"/>
+              </a:spcBef>
+              <a:defRPr sz="1019">
+                <a:solidFill>
+                  <a:srgbClr val="334155"/>
+                </a:solidFill>
+              </a:defRPr>
+            </a:pPr>
+            <a:r>
+              <a:t>split read/write path</a:t>
+            </a:r>
+          </a:p>
+          <a:p>
+            <a:pPr>
+              <a:spcBef>
+                <a:spcPts val="300"/>
+              </a:spcBef>
+              <a:defRPr sz="1019">
+                <a:solidFill>
+                  <a:srgbClr val="334155"/>
+                </a:solidFill>
+              </a:defRPr>
+            </a:pPr>
+            <a:r>
+              <a:t>avoid poor seam</a:t>
+            </a:r>
+          </a:p>
+        </p:txBody>
+      </p:sp>
+      <p:sp>
+        <p:nvSpPr>
+          <p:cNvPr id="7" name="Rounded Rectangle 6"/>
+          <p:cNvSpPr/>
+          <p:nvPr/>
+        </p:nvSpPr>
+        <p:spPr>
+          <a:xfrm>
+            <a:off x="914400" y="5715000"/>
+            <a:ext cx="10332720" cy="438912"/>
+          </a:xfrm>
+          <a:prstGeom prst="roundRect">
+            <a:avLst/>
+          </a:prstGeom>
+          <a:solidFill>
+            <a:srgbClr val="F8FAFC"/>
+          </a:solidFill>
+          <a:ln w="13970">
+            <a:solidFill>
+              <a:srgbClr val="94A3B8"/>
+            </a:solidFill>
+          </a:ln>
+        </p:spPr>
+        <p:style>
+          <a:lnRef idx="1">
+            <a:schemeClr val="accent1"/>
+          </a:lnRef>
+          <a:fillRef idx="3">
+            <a:schemeClr val="accent1"/>
+          </a:fillRef>
+          <a:effectRef idx="2">
+            <a:schemeClr val="accent1"/>
+          </a:effectRef>
+          <a:fontRef idx="minor">
+            <a:schemeClr val="lt1"/>
+          </a:fontRef>
+        </p:style>
+        <p:txBody>
+          <a:bodyPr rtlCol="0" anchor="t" lIns="109728" rIns="109728" tIns="73152"/>
+          <a:lstStyle/>
+          <a:p>
+            <a:pPr algn="ctr">
+              <a:defRPr sz="1300" b="1">
+                <a:solidFill>
+                  <a:srgbClr val="0F172A"/>
+                </a:solidFill>
+              </a:defRPr>
+            </a:pPr>
+            <a:r>
+              <a:t>Result: brownfield work lands in existing architecture instead of creating parallel implementations.</a:t>
+            </a:r>
+          </a:p>
+        </p:txBody>
+      </p:sp>
+      <p:sp>
+        <p:nvSpPr>
+          <p:cNvPr id="8" name="TextBox 7"/>
+          <p:cNvSpPr txBox="1"/>
+          <p:nvPr/>
+        </p:nvSpPr>
+        <p:spPr>
+          <a:xfrm>
+            <a:off x="411480" y="6446520"/>
+            <a:ext cx="6766560" cy="228600"/>
+          </a:xfrm>
+          <a:prstGeom prst="rect">
+            <a:avLst/>
+          </a:prstGeom>
+          <a:noFill/>
+        </p:spPr>
+        <p:txBody>
+          <a:bodyPr wrap="none">
+            <a:spAutoFit/>
+          </a:bodyPr>
+          <a:lstStyle/>
+          <a:p>
+            <a:pPr>
+              <a:defRPr sz="850">
+                <a:solidFill>
+                  <a:srgbClr val="566070"/>
+                </a:solidFill>
+              </a:defRPr>
+            </a:pPr>
+            <a:r>
+              <a:t>Claude Harness Engine v1.1.4   ·   Graph-Grounded Brownfield Discovery</a:t>
+            </a:r>
+          </a:p>
+        </p:txBody>
+      </p:sp>
+      <p:sp>
+        <p:nvSpPr>
+          <p:cNvPr id="9" name="TextBox 8"/>
+          <p:cNvSpPr txBox="1"/>
+          <p:nvPr/>
+        </p:nvSpPr>
+        <p:spPr>
+          <a:xfrm>
+            <a:off x="10972800" y="6446520"/>
+            <a:ext cx="731520" cy="228600"/>
+          </a:xfrm>
+          <a:prstGeom prst="rect">
+            <a:avLst/>
+          </a:prstGeom>
+          <a:noFill/>
+        </p:spPr>
+        <p:txBody>
+          <a:bodyPr wrap="none">
+            <a:spAutoFit/>
+          </a:bodyPr>
+          <a:lstStyle/>
+          <a:p>
+            <a:pPr algn="r">
+              <a:defRPr sz="850">
+                <a:solidFill>
+                  <a:srgbClr val="566070"/>
+                </a:solidFill>
+              </a:defRPr>
+            </a:pPr>
+            <a:r>
+              <a:t>36 / 36</a:t>
             </a:r>
           </a:p>
         </p:txBody>
@@ -35487,7 +36890,7 @@
                 </a:solidFill>
                 <a:latin typeface="Calibri"/>
               </a:rPr>
-              <a:t>4 / 34</a:t>
+              <a:t>4 / 36</a:t>
             </a:r>
           </a:p>
         </p:txBody>
@@ -35832,7 +37235,7 @@
                 </a:solidFill>
                 <a:latin typeface="Consolas"/>
               </a:rPr>
-              <a:t>├─ skills/  (23)  </a:t>
+              <a:t>├─ skills/  (25)  </a:t>
             </a:r>
             <a:r>
               <a:rPr sz="1000">
@@ -36324,7 +37727,7 @@
                 </a:solidFill>
                 <a:latin typeface="Calibri"/>
               </a:rPr>
-              <a:t>5 / 34</a:t>
+              <a:t>5 / 36</a:t>
             </a:r>
           </a:p>
         </p:txBody>
@@ -37549,7 +38952,7 @@
                 </a:solidFill>
                 <a:latin typeface="Calibri"/>
               </a:rPr>
-              <a:t>6 / 34</a:t>
+              <a:t>6 / 36</a:t>
             </a:r>
           </a:p>
         </p:txBody>
@@ -38344,7 +39747,7 @@
                 </a:solidFill>
                 <a:latin typeface="Calibri"/>
               </a:rPr>
-              <a:t>7 / 34</a:t>
+              <a:t>7 / 36</a:t>
             </a:r>
           </a:p>
         </p:txBody>
@@ -41336,7 +42739,7 @@
                 </a:solidFill>
                 <a:latin typeface="Calibri"/>
               </a:rPr>
-              <a:t>8 / 34</a:t>
+              <a:t>8 / 36</a:t>
             </a:r>
           </a:p>
         </p:txBody>
@@ -41476,7 +42879,7 @@
                 </a:solidFill>
                 <a:latin typeface="Calibri"/>
               </a:rPr>
-              <a:t>The 23 Skills, Grouped by Purpose</a:t>
+              <a:t>The 25 Skills, Grouped by Purpose</a:t>
             </a:r>
           </a:p>
         </p:txBody>
@@ -41883,50 +43286,27 @@
           </a:bodyPr>
           <a:lstStyle/>
           <a:p>
-            <a:pPr>
-              <a:spcAft>
-                <a:spcPts val="200"/>
-              </a:spcAft>
-            </a:pPr>
-            <a:r>
-              <a:rPr sz="1000" b="0">
-                <a:solidFill>
-                  <a:srgbClr val="F8FAFC"/>
-                </a:solidFill>
-                <a:latin typeface="Consolas"/>
-              </a:rPr>
+            <a:r>
               <a:t>▸ /brownfield</a:t>
             </a:r>
           </a:p>
           <a:p>
-            <a:pPr>
-              <a:spcAft>
-                <a:spcPts val="200"/>
-              </a:spcAft>
-            </a:pPr>
-            <a:r>
-              <a:rPr sz="1000" b="0">
-                <a:solidFill>
-                  <a:srgbClr val="F8FAFC"/>
-                </a:solidFill>
-                <a:latin typeface="Consolas"/>
-              </a:rPr>
+            <a:r>
+              <a:t>▸ /code-map</a:t>
+            </a:r>
+          </a:p>
+          <a:p>
+            <a:r>
+              <a:t>▸ /seam-finder</a:t>
+            </a:r>
+          </a:p>
+          <a:p>
+            <a:r>
               <a:t>▸ /vibe</a:t>
             </a:r>
           </a:p>
           <a:p>
-            <a:pPr>
-              <a:spcAft>
-                <a:spcPts val="200"/>
-              </a:spcAft>
-            </a:pPr>
-            <a:r>
-              <a:rPr sz="1000" b="0">
-                <a:solidFill>
-                  <a:srgbClr val="F8FAFC"/>
-                </a:solidFill>
-                <a:latin typeface="Consolas"/>
-              </a:rPr>
+            <a:r>
               <a:t>▸ /clarify</a:t>
             </a:r>
           </a:p>
@@ -42368,7 +43748,7 @@
                 </a:solidFill>
                 <a:latin typeface="Calibri"/>
               </a:rPr>
-              <a:t>9 / 34</a:t>
+              <a:t>9 / 36</a:t>
             </a:r>
           </a:p>
         </p:txBody>

</xml_diff>